<commit_message>
docs: Update README for HackFW submission and refresh Story Deck
- Reference HackFW hackathon with registration link
- Add About HackFW section explaining convergent technology theme
- Add HackFW Submission section with requirements checklist
- Update acknowledgments to credit HackFW organizers
- Include updated Trailmark Story Deck presentation

Co-Authored-By: Claude Sonnet 4.5 <noreply@anthropic.com>
</commit_message>
<xml_diff>
--- a/Trailmark_Story_Deck.pptx
+++ b/Trailmark_Story_Deck.pptx
@@ -15,9 +15,10 @@
     <p:sldId id="263" r:id="rId9"/>
     <p:sldId id="264" r:id="rId10"/>
     <p:sldId id="265" r:id="rId11"/>
+    <p:sldId id="266" r:id="rId12"/>
   </p:sldIdLst>
   <p:notesMasterIdLst>
-    <p:notesMasterId r:id="rId12"/>
+    <p:notesMasterId r:id="rId13"/>
   </p:notesMasterIdLst>
   <p:sldSz cx="9144000" cy="5143500"/>
   <p:notesSz cx="5143500" cy="9144000"/>
@@ -641,6 +642,94 @@
 </p:notes>
 </file>
 
+<file path=ppt/notesSlides/notesSlide11.xml><?xml version="1.0" encoding="utf-8"?>
+<p:notes xmlns:a="http://schemas.openxmlformats.org/drawingml/2006/main" xmlns:r="http://schemas.openxmlformats.org/officeDocument/2006/relationships" xmlns:p="http://schemas.openxmlformats.org/presentationml/2006/main">
+  <p:cSld>
+    <p:spTree>
+      <p:nvGrpSpPr>
+        <p:cNvPr id="1" name=""/>
+        <p:cNvGrpSpPr/>
+        <p:nvPr/>
+      </p:nvGrpSpPr>
+      <p:grpSpPr>
+        <a:xfrm>
+          <a:off x="0" y="0"/>
+          <a:ext cx="0" cy="0"/>
+          <a:chOff x="0" y="0"/>
+          <a:chExt cx="0" cy="0"/>
+        </a:xfrm>
+      </p:grpSpPr>
+      <p:sp>
+        <p:nvSpPr>
+          <p:cNvPr id="2" name="Slide Image Placeholder 1"/>
+          <p:cNvSpPr>
+            <a:spLocks noGrp="1" noRot="1" noChangeAspect="1"/>
+          </p:cNvSpPr>
+          <p:nvPr>
+            <p:ph type="sldImg"/>
+          </p:nvPr>
+        </p:nvSpPr>
+        <p:spPr/>
+      </p:sp>
+      <p:sp>
+        <p:nvSpPr>
+          <p:cNvPr id="3" name="Notes Placeholder 2"/>
+          <p:cNvSpPr>
+            <a:spLocks noGrp="1"/>
+          </p:cNvSpPr>
+          <p:nvPr>
+            <p:ph type="body" idx="1"/>
+          </p:nvPr>
+        </p:nvSpPr>
+        <p:spPr/>
+        <p:txBody>
+          <a:bodyPr/>
+          <a:lstStyle/>
+          <a:p>
+            <a:r>
+              <a:rPr lang="en-US" dirty="0"/>
+              <a:t/>
+            </a:r>
+            <a:endParaRPr lang="en-US" dirty="0"/>
+          </a:p>
+        </p:txBody>
+      </p:sp>
+      <p:sp>
+        <p:nvSpPr>
+          <p:cNvPr id="4" name="Slide Number Placeholder 3"/>
+          <p:cNvSpPr>
+            <a:spLocks noGrp="1"/>
+          </p:cNvSpPr>
+          <p:nvPr>
+            <p:ph type="sldNum" sz="quarter" idx="10"/>
+          </p:nvPr>
+        </p:nvSpPr>
+        <p:spPr/>
+        <p:txBody>
+          <a:bodyPr/>
+          <a:lstStyle/>
+          <a:p>
+            <a:fld id="{F7021451-1387-4CA6-816F-3879F97B5CBC}" type="slidenum">
+              <a:rPr lang="en-US"/>
+              <a:t>11</a:t>
+            </a:fld>
+            <a:endParaRPr lang="en-US"/>
+          </a:p>
+        </p:txBody>
+      </p:sp>
+    </p:spTree>
+    <p:extLst>
+      <p:ext uri="{BB962C8B-B14F-4D97-AF65-F5344CB8AC3E}">
+        <p14:creationId xmlns:p14="http://schemas.microsoft.com/office/powerpoint/2010/main" val="1024086991"/>
+      </p:ext>
+    </p:extLst>
+  </p:cSld>
+  <p:clrMapOvr>
+    <a:masterClrMapping/>
+  </p:clrMapOvr>
+</p:notes>
+</file>
+
 <file path=ppt/notesSlides/notesSlide2.xml><?xml version="1.0" encoding="utf-8"?>
 <p:notes xmlns:a="http://schemas.openxmlformats.org/drawingml/2006/main" xmlns:r="http://schemas.openxmlformats.org/officeDocument/2006/relationships" xmlns:p="http://schemas.openxmlformats.org/presentationml/2006/main">
   <p:cSld>
@@ -1879,297 +1968,6 @@
           </a:p>
         </p:txBody>
       </p:sp>
-      <p:sp>
-        <p:nvSpPr>
-          <p:cNvPr id="7" name="Shape 4"/>
-          <p:cNvSpPr/>
-          <p:nvPr/>
-        </p:nvSpPr>
-        <p:spPr>
-          <a:xfrm>
-            <a:off x="6949440" y="1188720"/>
-            <a:ext cx="1920240" cy="1005840"/>
-          </a:xfrm>
-          <a:prstGeom prst="rect">
-            <a:avLst/>
-          </a:prstGeom>
-          <a:solidFill>
-            <a:srgbClr val="1F2937"/>
-          </a:solidFill>
-          <a:ln w="12700">
-            <a:solidFill>
-              <a:srgbClr val="374151"/>
-            </a:solidFill>
-            <a:prstDash val="solid"/>
-          </a:ln>
-        </p:spPr>
-      </p:sp>
-      <p:sp>
-        <p:nvSpPr>
-          <p:cNvPr id="8" name="Text 5"/>
-          <p:cNvSpPr/>
-          <p:nvPr/>
-        </p:nvSpPr>
-        <p:spPr>
-          <a:xfrm>
-            <a:off x="6949440" y="1234440"/>
-            <a:ext cx="1920240" cy="548640"/>
-          </a:xfrm>
-          <a:prstGeom prst="rect">
-            <a:avLst/>
-          </a:prstGeom>
-          <a:noFill/>
-          <a:ln/>
-        </p:spPr>
-        <p:txBody>
-          <a:bodyPr wrap="square" lIns="0" tIns="0" rIns="0" bIns="0" rtlCol="0" anchor="ctr"/>
-          <a:lstStyle/>
-          <a:p>
-            <a:pPr algn="ctr" indent="0" marL="0">
-              <a:buNone/>
-            </a:pPr>
-            <a:r>
-              <a:rPr lang="en-US" sz="3200" b="1" dirty="0">
-                <a:solidFill>
-                  <a:srgbClr val="EA580C"/>
-                </a:solidFill>
-              </a:rPr>
-              <a:t>30%</a:t>
-            </a:r>
-            <a:endParaRPr lang="en-US" sz="3200" dirty="0"/>
-          </a:p>
-        </p:txBody>
-      </p:sp>
-      <p:sp>
-        <p:nvSpPr>
-          <p:cNvPr id="9" name="Text 6"/>
-          <p:cNvSpPr/>
-          <p:nvPr/>
-        </p:nvSpPr>
-        <p:spPr>
-          <a:xfrm>
-            <a:off x="6949440" y="1783080"/>
-            <a:ext cx="1920240" cy="320040"/>
-          </a:xfrm>
-          <a:prstGeom prst="rect">
-            <a:avLst/>
-          </a:prstGeom>
-          <a:noFill/>
-          <a:ln/>
-        </p:spPr>
-        <p:txBody>
-          <a:bodyPr wrap="square" lIns="0" tIns="0" rIns="0" bIns="0" rtlCol="0" anchor="ctr"/>
-          <a:lstStyle/>
-          <a:p>
-            <a:pPr algn="ctr" indent="0" marL="0">
-              <a:buNone/>
-            </a:pPr>
-            <a:r>
-              <a:rPr lang="en-US" sz="1000" dirty="0">
-                <a:solidFill>
-                  <a:srgbClr val="9CA3AF"/>
-                </a:solidFill>
-              </a:rPr>
-              <a:t>Platform Cut</a:t>
-            </a:r>
-            <a:endParaRPr lang="en-US" sz="1000" dirty="0"/>
-          </a:p>
-        </p:txBody>
-      </p:sp>
-      <p:sp>
-        <p:nvSpPr>
-          <p:cNvPr id="10" name="Shape 7"/>
-          <p:cNvSpPr/>
-          <p:nvPr/>
-        </p:nvSpPr>
-        <p:spPr>
-          <a:xfrm>
-            <a:off x="6949440" y="2331720"/>
-            <a:ext cx="1920240" cy="1005840"/>
-          </a:xfrm>
-          <a:prstGeom prst="rect">
-            <a:avLst/>
-          </a:prstGeom>
-          <a:solidFill>
-            <a:srgbClr val="1F2937"/>
-          </a:solidFill>
-          <a:ln w="12700">
-            <a:solidFill>
-              <a:srgbClr val="374151"/>
-            </a:solidFill>
-            <a:prstDash val="solid"/>
-          </a:ln>
-        </p:spPr>
-      </p:sp>
-      <p:sp>
-        <p:nvSpPr>
-          <p:cNvPr id="11" name="Text 8"/>
-          <p:cNvSpPr/>
-          <p:nvPr/>
-        </p:nvSpPr>
-        <p:spPr>
-          <a:xfrm>
-            <a:off x="6949440" y="2377440"/>
-            <a:ext cx="1920240" cy="548640"/>
-          </a:xfrm>
-          <a:prstGeom prst="rect">
-            <a:avLst/>
-          </a:prstGeom>
-          <a:noFill/>
-          <a:ln/>
-        </p:spPr>
-        <p:txBody>
-          <a:bodyPr wrap="square" lIns="0" tIns="0" rIns="0" bIns="0" rtlCol="0" anchor="ctr"/>
-          <a:lstStyle/>
-          <a:p>
-            <a:pPr algn="ctr" indent="0" marL="0">
-              <a:buNone/>
-            </a:pPr>
-            <a:r>
-              <a:rPr lang="en-US" sz="3200" b="1" dirty="0">
-                <a:solidFill>
-                  <a:srgbClr val="EA580C"/>
-                </a:solidFill>
-              </a:rPr>
-              <a:t>90</a:t>
-            </a:r>
-            <a:endParaRPr lang="en-US" sz="3200" dirty="0"/>
-          </a:p>
-        </p:txBody>
-      </p:sp>
-      <p:sp>
-        <p:nvSpPr>
-          <p:cNvPr id="12" name="Text 9"/>
-          <p:cNvSpPr/>
-          <p:nvPr/>
-        </p:nvSpPr>
-        <p:spPr>
-          <a:xfrm>
-            <a:off x="6949440" y="2926080"/>
-            <a:ext cx="1920240" cy="320040"/>
-          </a:xfrm>
-          <a:prstGeom prst="rect">
-            <a:avLst/>
-          </a:prstGeom>
-          <a:noFill/>
-          <a:ln/>
-        </p:spPr>
-        <p:txBody>
-          <a:bodyPr wrap="square" lIns="0" tIns="0" rIns="0" bIns="0" rtlCol="0" anchor="ctr"/>
-          <a:lstStyle/>
-          <a:p>
-            <a:pPr algn="ctr" indent="0" marL="0">
-              <a:buNone/>
-            </a:pPr>
-            <a:r>
-              <a:rPr lang="en-US" sz="1000" dirty="0">
-                <a:solidFill>
-                  <a:srgbClr val="9CA3AF"/>
-                </a:solidFill>
-              </a:rPr>
-              <a:t>Days to Get Paid</a:t>
-            </a:r>
-            <a:endParaRPr lang="en-US" sz="1000" dirty="0"/>
-          </a:p>
-        </p:txBody>
-      </p:sp>
-      <p:sp>
-        <p:nvSpPr>
-          <p:cNvPr id="13" name="Shape 10"/>
-          <p:cNvSpPr/>
-          <p:nvPr/>
-        </p:nvSpPr>
-        <p:spPr>
-          <a:xfrm>
-            <a:off x="6949440" y="3474720"/>
-            <a:ext cx="1920240" cy="1005840"/>
-          </a:xfrm>
-          <a:prstGeom prst="rect">
-            <a:avLst/>
-          </a:prstGeom>
-          <a:solidFill>
-            <a:srgbClr val="1F2937"/>
-          </a:solidFill>
-          <a:ln w="12700">
-            <a:solidFill>
-              <a:srgbClr val="374151"/>
-            </a:solidFill>
-            <a:prstDash val="solid"/>
-          </a:ln>
-        </p:spPr>
-      </p:sp>
-      <p:sp>
-        <p:nvSpPr>
-          <p:cNvPr id="14" name="Text 11"/>
-          <p:cNvSpPr/>
-          <p:nvPr/>
-        </p:nvSpPr>
-        <p:spPr>
-          <a:xfrm>
-            <a:off x="6949440" y="3520440"/>
-            <a:ext cx="1920240" cy="548640"/>
-          </a:xfrm>
-          <a:prstGeom prst="rect">
-            <a:avLst/>
-          </a:prstGeom>
-          <a:noFill/>
-          <a:ln/>
-        </p:spPr>
-        <p:txBody>
-          <a:bodyPr wrap="square" lIns="0" tIns="0" rIns="0" bIns="0" rtlCol="0" anchor="ctr"/>
-          <a:lstStyle/>
-          <a:p>
-            <a:pPr algn="ctr" indent="0" marL="0">
-              <a:buNone/>
-            </a:pPr>
-            <a:r>
-              <a:rPr lang="en-US" sz="3200" b="1" dirty="0">
-                <a:solidFill>
-                  <a:srgbClr val="EA580C"/>
-                </a:solidFill>
-              </a:rPr>
-              <a:t>$0</a:t>
-            </a:r>
-            <a:endParaRPr lang="en-US" sz="3200" dirty="0"/>
-          </a:p>
-        </p:txBody>
-      </p:sp>
-      <p:sp>
-        <p:nvSpPr>
-          <p:cNvPr id="15" name="Text 12"/>
-          <p:cNvSpPr/>
-          <p:nvPr/>
-        </p:nvSpPr>
-        <p:spPr>
-          <a:xfrm>
-            <a:off x="6949440" y="4069080"/>
-            <a:ext cx="1920240" cy="320040"/>
-          </a:xfrm>
-          <a:prstGeom prst="rect">
-            <a:avLst/>
-          </a:prstGeom>
-          <a:noFill/>
-          <a:ln/>
-        </p:spPr>
-        <p:txBody>
-          <a:bodyPr wrap="square" lIns="0" tIns="0" rIns="0" bIns="0" rtlCol="0" anchor="ctr"/>
-          <a:lstStyle/>
-          <a:p>
-            <a:pPr algn="ctr" indent="0" marL="0">
-              <a:buNone/>
-            </a:pPr>
-            <a:r>
-              <a:rPr lang="en-US" sz="1000" dirty="0">
-                <a:solidFill>
-                  <a:srgbClr val="9CA3AF"/>
-                </a:solidFill>
-              </a:rPr>
-              <a:t>Reputation Portable</a:t>
-            </a:r>
-            <a:endParaRPr lang="en-US" sz="1000" dirty="0"/>
-          </a:p>
-        </p:txBody>
-      </p:sp>
     </p:spTree>
   </p:cSld>
   <p:clrMapOvr>
@@ -2181,6 +1979,1091 @@
 <file path=ppt/slides/slide10.xml><?xml version="1.0" encoding="utf-8"?>
 <p:sld xmlns:a="http://schemas.openxmlformats.org/drawingml/2006/main" xmlns:r="http://schemas.openxmlformats.org/officeDocument/2006/relationships" xmlns:p="http://schemas.openxmlformats.org/presentationml/2006/main">
   <p:cSld name="Slide 10">
+    <p:bg>
+      <p:bgPr>
+        <a:solidFill>
+          <a:srgbClr val="1F2937"/>
+        </a:solidFill>
+      </p:bgPr>
+    </p:bg>
+    <p:spTree>
+      <p:nvGrpSpPr>
+        <p:cNvPr id="1" name=""/>
+        <p:cNvGrpSpPr/>
+        <p:nvPr/>
+      </p:nvGrpSpPr>
+      <p:grpSpPr>
+        <a:xfrm>
+          <a:off x="0" y="0"/>
+          <a:ext cx="0" cy="0"/>
+          <a:chOff x="0" y="0"/>
+          <a:chExt cx="0" cy="0"/>
+        </a:xfrm>
+      </p:grpSpPr>
+      <p:sp>
+        <p:nvSpPr>
+          <p:cNvPr id="2" name="Shape 0"/>
+          <p:cNvSpPr/>
+          <p:nvPr/>
+        </p:nvSpPr>
+        <p:spPr>
+          <a:xfrm>
+            <a:off x="0" y="0"/>
+            <a:ext cx="109728" cy="5143500"/>
+          </a:xfrm>
+          <a:prstGeom prst="rect">
+            <a:avLst/>
+          </a:prstGeom>
+          <a:solidFill>
+            <a:srgbClr val="F59E0B"/>
+          </a:solidFill>
+          <a:ln w="12700">
+            <a:solidFill>
+              <a:srgbClr val="F59E0B"/>
+            </a:solidFill>
+            <a:prstDash val="solid"/>
+          </a:ln>
+        </p:spPr>
+      </p:sp>
+      <p:sp>
+        <p:nvSpPr>
+          <p:cNvPr id="3" name="Text 1"/>
+          <p:cNvSpPr/>
+          <p:nvPr/>
+        </p:nvSpPr>
+        <p:spPr>
+          <a:xfrm>
+            <a:off x="320040" y="274320"/>
+            <a:ext cx="4572000" cy="320040"/>
+          </a:xfrm>
+          <a:prstGeom prst="rect">
+            <a:avLst/>
+          </a:prstGeom>
+          <a:noFill/>
+          <a:ln/>
+        </p:spPr>
+        <p:txBody>
+          <a:bodyPr wrap="square" lIns="0" tIns="0" rIns="0" bIns="0" rtlCol="0" anchor="ctr"/>
+          <a:lstStyle/>
+          <a:p>
+            <a:pPr indent="0" marL="0">
+              <a:buNone/>
+            </a:pPr>
+            <a:r>
+              <a:rPr lang="en-US" sz="1100" b="1" spc="400" kern="0" dirty="0">
+                <a:solidFill>
+                  <a:srgbClr val="F59E0B"/>
+                </a:solidFill>
+              </a:rPr>
+              <a:t>INTEGRATION</a:t>
+            </a:r>
+            <a:endParaRPr lang="en-US" sz="1100" dirty="0"/>
+          </a:p>
+        </p:txBody>
+      </p:sp>
+      <p:sp>
+        <p:nvSpPr>
+          <p:cNvPr id="4" name="Text 2"/>
+          <p:cNvSpPr/>
+          <p:nvPr/>
+        </p:nvSpPr>
+        <p:spPr>
+          <a:xfrm>
+            <a:off x="320040" y="640080"/>
+            <a:ext cx="8503920" cy="1234440"/>
+          </a:xfrm>
+          <a:prstGeom prst="rect">
+            <a:avLst/>
+          </a:prstGeom>
+          <a:noFill/>
+          <a:ln/>
+        </p:spPr>
+        <p:txBody>
+          <a:bodyPr wrap="square" lIns="0" tIns="0" rIns="0" bIns="0" rtlCol="0" anchor="ctr"/>
+          <a:lstStyle/>
+          <a:p>
+            <a:pPr indent="0" marL="0">
+              <a:lnSpc>
+                <a:spcPct val="110000"/>
+              </a:lnSpc>
+              <a:buNone/>
+            </a:pPr>
+            <a:r>
+              <a:rPr lang="en-US" sz="4400" b="1" dirty="0">
+                <a:solidFill>
+                  <a:srgbClr val="FFFFFF"/>
+                </a:solidFill>
+                <a:latin typeface="Arial Black" pitchFamily="34" charset="0"/>
+                <a:ea typeface="Arial Black" pitchFamily="34" charset="-122"/>
+                <a:cs typeface="Arial Black" pitchFamily="34" charset="-120"/>
+              </a:rPr>
+              <a:t>Works with what</a:t>
+            </a:r>
+            <a:endParaRPr lang="en-US" sz="4400" dirty="0"/>
+          </a:p>
+          <a:p>
+            <a:pPr indent="0" marL="0">
+              <a:lnSpc>
+                <a:spcPct val="110000"/>
+              </a:lnSpc>
+              <a:buNone/>
+            </a:pPr>
+            <a:r>
+              <a:rPr lang="en-US" sz="4400" b="1" dirty="0">
+                <a:solidFill>
+                  <a:srgbClr val="FFFFFF"/>
+                </a:solidFill>
+                <a:latin typeface="Arial Black" pitchFamily="34" charset="0"/>
+                <a:ea typeface="Arial Black" pitchFamily="34" charset="-122"/>
+                <a:cs typeface="Arial Black" pitchFamily="34" charset="-120"/>
+              </a:rPr>
+              <a:t>already exists.</a:t>
+            </a:r>
+            <a:endParaRPr lang="en-US" sz="4400" dirty="0"/>
+          </a:p>
+        </p:txBody>
+      </p:sp>
+      <p:sp>
+        <p:nvSpPr>
+          <p:cNvPr id="5" name="Text 3"/>
+          <p:cNvSpPr/>
+          <p:nvPr/>
+        </p:nvSpPr>
+        <p:spPr>
+          <a:xfrm>
+            <a:off x="320040" y="1920240"/>
+            <a:ext cx="8503920" cy="365760"/>
+          </a:xfrm>
+          <a:prstGeom prst="rect">
+            <a:avLst/>
+          </a:prstGeom>
+          <a:noFill/>
+          <a:ln/>
+        </p:spPr>
+        <p:txBody>
+          <a:bodyPr wrap="square" lIns="0" tIns="0" rIns="0" bIns="0" rtlCol="0" anchor="ctr"/>
+          <a:lstStyle/>
+          <a:p>
+            <a:pPr indent="0" marL="0">
+              <a:buNone/>
+            </a:pPr>
+            <a:r>
+              <a:rPr lang="en-US" sz="1500" i="1" dirty="0">
+                <a:solidFill>
+                  <a:srgbClr val="9CA3AF"/>
+                </a:solidFill>
+              </a:rPr>
+              <a:t>We don't replace licensing. We make it navigable and portable.</a:t>
+            </a:r>
+            <a:endParaRPr lang="en-US" sz="1500" dirty="0"/>
+          </a:p>
+        </p:txBody>
+      </p:sp>
+      <p:sp>
+        <p:nvSpPr>
+          <p:cNvPr id="6" name="Shape 4"/>
+          <p:cNvSpPr/>
+          <p:nvPr/>
+        </p:nvSpPr>
+        <p:spPr>
+          <a:xfrm>
+            <a:off x="274320" y="2468880"/>
+            <a:ext cx="4160520" cy="685800"/>
+          </a:xfrm>
+          <a:prstGeom prst="rect">
+            <a:avLst/>
+          </a:prstGeom>
+          <a:solidFill>
+            <a:srgbClr val="374151"/>
+          </a:solidFill>
+          <a:ln w="12700">
+            <a:solidFill>
+              <a:srgbClr val="374151"/>
+            </a:solidFill>
+            <a:prstDash val="solid"/>
+          </a:ln>
+        </p:spPr>
+      </p:sp>
+      <p:sp>
+        <p:nvSpPr>
+          <p:cNvPr id="7" name="Shape 5"/>
+          <p:cNvSpPr/>
+          <p:nvPr/>
+        </p:nvSpPr>
+        <p:spPr>
+          <a:xfrm>
+            <a:off x="274320" y="2468880"/>
+            <a:ext cx="54864" cy="685800"/>
+          </a:xfrm>
+          <a:prstGeom prst="rect">
+            <a:avLst/>
+          </a:prstGeom>
+          <a:solidFill>
+            <a:srgbClr val="F59E0B"/>
+          </a:solidFill>
+          <a:ln w="12700">
+            <a:solidFill>
+              <a:srgbClr val="F59E0B"/>
+            </a:solidFill>
+            <a:prstDash val="solid"/>
+          </a:ln>
+        </p:spPr>
+      </p:sp>
+      <p:pic>
+        <p:nvPicPr>
+          <p:cNvPr id="8" name="Image 0" descr="preencoded.png">    </p:cNvPr>
+          <p:cNvPicPr>
+            <a:picLocks noChangeAspect="1"/>
+          </p:cNvPicPr>
+          <p:nvPr/>
+        </p:nvPicPr>
+        <p:blipFill>
+          <a:blip r:embed="rId1"/>
+          <a:stretch>
+            <a:fillRect/>
+          </a:stretch>
+        </p:blipFill>
+        <p:spPr>
+          <a:xfrm>
+            <a:off x="411480" y="2651760"/>
+            <a:ext cx="292608" cy="292608"/>
+          </a:xfrm>
+          <a:prstGeom prst="rect">
+            <a:avLst/>
+          </a:prstGeom>
+        </p:spPr>
+      </p:pic>
+      <p:sp>
+        <p:nvSpPr>
+          <p:cNvPr id="9" name="Text 6"/>
+          <p:cNvSpPr/>
+          <p:nvPr/>
+        </p:nvSpPr>
+        <p:spPr>
+          <a:xfrm>
+            <a:off x="822960" y="2542032"/>
+            <a:ext cx="3474720" cy="292608"/>
+          </a:xfrm>
+          <a:prstGeom prst="rect">
+            <a:avLst/>
+          </a:prstGeom>
+          <a:noFill/>
+          <a:ln/>
+        </p:spPr>
+        <p:txBody>
+          <a:bodyPr wrap="square" lIns="0" tIns="0" rIns="0" bIns="0" rtlCol="0" anchor="ctr"/>
+          <a:lstStyle/>
+          <a:p>
+            <a:pPr indent="0" marL="0">
+              <a:buNone/>
+            </a:pPr>
+            <a:r>
+              <a:rPr lang="en-US" sz="1300" b="1" dirty="0">
+                <a:solidFill>
+                  <a:srgbClr val="FFFFFF"/>
+                </a:solidFill>
+              </a:rPr>
+              <a:t>TDLR Licenses</a:t>
+            </a:r>
+            <a:endParaRPr lang="en-US" sz="1300" dirty="0"/>
+          </a:p>
+        </p:txBody>
+      </p:sp>
+      <p:sp>
+        <p:nvSpPr>
+          <p:cNvPr id="10" name="Text 7"/>
+          <p:cNvSpPr/>
+          <p:nvPr/>
+        </p:nvSpPr>
+        <p:spPr>
+          <a:xfrm>
+            <a:off x="822960" y="2852928"/>
+            <a:ext cx="3474720" cy="256032"/>
+          </a:xfrm>
+          <a:prstGeom prst="rect">
+            <a:avLst/>
+          </a:prstGeom>
+          <a:noFill/>
+          <a:ln/>
+        </p:spPr>
+        <p:txBody>
+          <a:bodyPr wrap="square" lIns="0" tIns="0" rIns="0" bIns="0" rtlCol="0" anchor="ctr"/>
+          <a:lstStyle/>
+          <a:p>
+            <a:pPr indent="0" marL="0">
+              <a:buNone/>
+            </a:pPr>
+            <a:r>
+              <a:rPr lang="en-US" sz="1100" dirty="0">
+                <a:solidFill>
+                  <a:srgbClr val="9CA3AF"/>
+                </a:solidFill>
+                <a:latin typeface="Calibri" pitchFamily="34" charset="0"/>
+                <a:ea typeface="Calibri" pitchFamily="34" charset="-122"/>
+                <a:cs typeface="Calibri" pitchFamily="34" charset="-120"/>
+              </a:rPr>
+              <a:t>Verified on-chain via API. Worker-owned attestation.</a:t>
+            </a:r>
+            <a:endParaRPr lang="en-US" sz="1100" dirty="0"/>
+          </a:p>
+        </p:txBody>
+      </p:sp>
+      <p:sp>
+        <p:nvSpPr>
+          <p:cNvPr id="11" name="Shape 8"/>
+          <p:cNvSpPr/>
+          <p:nvPr/>
+        </p:nvSpPr>
+        <p:spPr>
+          <a:xfrm>
+            <a:off x="4617720" y="2468880"/>
+            <a:ext cx="4160520" cy="685800"/>
+          </a:xfrm>
+          <a:prstGeom prst="rect">
+            <a:avLst/>
+          </a:prstGeom>
+          <a:solidFill>
+            <a:srgbClr val="374151"/>
+          </a:solidFill>
+          <a:ln w="12700">
+            <a:solidFill>
+              <a:srgbClr val="374151"/>
+            </a:solidFill>
+            <a:prstDash val="solid"/>
+          </a:ln>
+        </p:spPr>
+      </p:sp>
+      <p:sp>
+        <p:nvSpPr>
+          <p:cNvPr id="12" name="Shape 9"/>
+          <p:cNvSpPr/>
+          <p:nvPr/>
+        </p:nvSpPr>
+        <p:spPr>
+          <a:xfrm>
+            <a:off x="4617720" y="2468880"/>
+            <a:ext cx="54864" cy="685800"/>
+          </a:xfrm>
+          <a:prstGeom prst="rect">
+            <a:avLst/>
+          </a:prstGeom>
+          <a:solidFill>
+            <a:srgbClr val="F59E0B"/>
+          </a:solidFill>
+          <a:ln w="12700">
+            <a:solidFill>
+              <a:srgbClr val="F59E0B"/>
+            </a:solidFill>
+            <a:prstDash val="solid"/>
+          </a:ln>
+        </p:spPr>
+      </p:sp>
+      <p:pic>
+        <p:nvPicPr>
+          <p:cNvPr id="13" name="Image 1" descr="preencoded.png">    </p:cNvPr>
+          <p:cNvPicPr>
+            <a:picLocks noChangeAspect="1"/>
+          </p:cNvPicPr>
+          <p:nvPr/>
+        </p:nvPicPr>
+        <p:blipFill>
+          <a:blip r:embed="rId2"/>
+          <a:stretch>
+            <a:fillRect/>
+          </a:stretch>
+        </p:blipFill>
+        <p:spPr>
+          <a:xfrm>
+            <a:off x="4754880" y="2651760"/>
+            <a:ext cx="292608" cy="292608"/>
+          </a:xfrm>
+          <a:prstGeom prst="rect">
+            <a:avLst/>
+          </a:prstGeom>
+        </p:spPr>
+      </p:pic>
+      <p:sp>
+        <p:nvSpPr>
+          <p:cNvPr id="14" name="Text 10"/>
+          <p:cNvSpPr/>
+          <p:nvPr/>
+        </p:nvSpPr>
+        <p:spPr>
+          <a:xfrm>
+            <a:off x="5166360" y="2542032"/>
+            <a:ext cx="3474720" cy="292608"/>
+          </a:xfrm>
+          <a:prstGeom prst="rect">
+            <a:avLst/>
+          </a:prstGeom>
+          <a:noFill/>
+          <a:ln/>
+        </p:spPr>
+        <p:txBody>
+          <a:bodyPr wrap="square" lIns="0" tIns="0" rIns="0" bIns="0" rtlCol="0" anchor="ctr"/>
+          <a:lstStyle/>
+          <a:p>
+            <a:pPr indent="0" marL="0">
+              <a:buNone/>
+            </a:pPr>
+            <a:r>
+              <a:rPr lang="en-US" sz="1300" b="1" dirty="0">
+                <a:solidFill>
+                  <a:srgbClr val="FFFFFF"/>
+                </a:solidFill>
+              </a:rPr>
+              <a:t>Bonfire Procurement</a:t>
+            </a:r>
+            <a:endParaRPr lang="en-US" sz="1300" dirty="0"/>
+          </a:p>
+        </p:txBody>
+      </p:sp>
+      <p:sp>
+        <p:nvSpPr>
+          <p:cNvPr id="15" name="Text 11"/>
+          <p:cNvSpPr/>
+          <p:nvPr/>
+        </p:nvSpPr>
+        <p:spPr>
+          <a:xfrm>
+            <a:off x="5166360" y="2852928"/>
+            <a:ext cx="3474720" cy="256032"/>
+          </a:xfrm>
+          <a:prstGeom prst="rect">
+            <a:avLst/>
+          </a:prstGeom>
+          <a:noFill/>
+          <a:ln/>
+        </p:spPr>
+        <p:txBody>
+          <a:bodyPr wrap="square" lIns="0" tIns="0" rIns="0" bIns="0" rtlCol="0" anchor="ctr"/>
+          <a:lstStyle/>
+          <a:p>
+            <a:pPr indent="0" marL="0">
+              <a:buNone/>
+            </a:pPr>
+            <a:r>
+              <a:rPr lang="en-US" sz="1100" dirty="0">
+                <a:solidFill>
+                  <a:srgbClr val="9CA3AF"/>
+                </a:solidFill>
+                <a:latin typeface="Calibri" pitchFamily="34" charset="0"/>
+                <a:ea typeface="Calibri" pitchFamily="34" charset="-122"/>
+                <a:cs typeface="Calibri" pitchFamily="34" charset="-120"/>
+              </a:rPr>
+              <a:t>Scout agent monitors RFPs. Workers get alerts before the deadline.</a:t>
+            </a:r>
+            <a:endParaRPr lang="en-US" sz="1100" dirty="0"/>
+          </a:p>
+        </p:txBody>
+      </p:sp>
+      <p:sp>
+        <p:nvSpPr>
+          <p:cNvPr id="16" name="Shape 12"/>
+          <p:cNvSpPr/>
+          <p:nvPr/>
+        </p:nvSpPr>
+        <p:spPr>
+          <a:xfrm>
+            <a:off x="274320" y="3337560"/>
+            <a:ext cx="4160520" cy="685800"/>
+          </a:xfrm>
+          <a:prstGeom prst="rect">
+            <a:avLst/>
+          </a:prstGeom>
+          <a:solidFill>
+            <a:srgbClr val="374151"/>
+          </a:solidFill>
+          <a:ln w="12700">
+            <a:solidFill>
+              <a:srgbClr val="374151"/>
+            </a:solidFill>
+            <a:prstDash val="solid"/>
+          </a:ln>
+        </p:spPr>
+      </p:sp>
+      <p:sp>
+        <p:nvSpPr>
+          <p:cNvPr id="17" name="Shape 13"/>
+          <p:cNvSpPr/>
+          <p:nvPr/>
+        </p:nvSpPr>
+        <p:spPr>
+          <a:xfrm>
+            <a:off x="274320" y="3337560"/>
+            <a:ext cx="54864" cy="685800"/>
+          </a:xfrm>
+          <a:prstGeom prst="rect">
+            <a:avLst/>
+          </a:prstGeom>
+          <a:solidFill>
+            <a:srgbClr val="F59E0B"/>
+          </a:solidFill>
+          <a:ln w="12700">
+            <a:solidFill>
+              <a:srgbClr val="F59E0B"/>
+            </a:solidFill>
+            <a:prstDash val="solid"/>
+          </a:ln>
+        </p:spPr>
+      </p:sp>
+      <p:pic>
+        <p:nvPicPr>
+          <p:cNvPr id="18" name="Image 2" descr="preencoded.png">    </p:cNvPr>
+          <p:cNvPicPr>
+            <a:picLocks noChangeAspect="1"/>
+          </p:cNvPicPr>
+          <p:nvPr/>
+        </p:nvPicPr>
+        <p:blipFill>
+          <a:blip r:embed="rId3"/>
+          <a:stretch>
+            <a:fillRect/>
+          </a:stretch>
+        </p:blipFill>
+        <p:spPr>
+          <a:xfrm>
+            <a:off x="411480" y="3520440"/>
+            <a:ext cx="292608" cy="292608"/>
+          </a:xfrm>
+          <a:prstGeom prst="rect">
+            <a:avLst/>
+          </a:prstGeom>
+        </p:spPr>
+      </p:pic>
+      <p:sp>
+        <p:nvSpPr>
+          <p:cNvPr id="19" name="Text 14"/>
+          <p:cNvSpPr/>
+          <p:nvPr/>
+        </p:nvSpPr>
+        <p:spPr>
+          <a:xfrm>
+            <a:off x="822960" y="3410712"/>
+            <a:ext cx="3474720" cy="292608"/>
+          </a:xfrm>
+          <a:prstGeom prst="rect">
+            <a:avLst/>
+          </a:prstGeom>
+          <a:noFill/>
+          <a:ln/>
+        </p:spPr>
+        <p:txBody>
+          <a:bodyPr wrap="square" lIns="0" tIns="0" rIns="0" bIns="0" rtlCol="0" anchor="ctr"/>
+          <a:lstStyle/>
+          <a:p>
+            <a:pPr indent="0" marL="0">
+              <a:buNone/>
+            </a:pPr>
+            <a:r>
+              <a:rPr lang="en-US" sz="1300" b="1" dirty="0">
+                <a:solidFill>
+                  <a:srgbClr val="FFFFFF"/>
+                </a:solidFill>
+              </a:rPr>
+              <a:t>City Bond Programs</a:t>
+            </a:r>
+            <a:endParaRPr lang="en-US" sz="1300" dirty="0"/>
+          </a:p>
+        </p:txBody>
+      </p:sp>
+      <p:sp>
+        <p:nvSpPr>
+          <p:cNvPr id="20" name="Text 15"/>
+          <p:cNvSpPr/>
+          <p:nvPr/>
+        </p:nvSpPr>
+        <p:spPr>
+          <a:xfrm>
+            <a:off x="822960" y="3721608"/>
+            <a:ext cx="3474720" cy="256032"/>
+          </a:xfrm>
+          <a:prstGeom prst="rect">
+            <a:avLst/>
+          </a:prstGeom>
+          <a:noFill/>
+          <a:ln/>
+        </p:spPr>
+        <p:txBody>
+          <a:bodyPr wrap="square" lIns="0" tIns="0" rIns="0" bIns="0" rtlCol="0" anchor="ctr"/>
+          <a:lstStyle/>
+          <a:p>
+            <a:pPr indent="0" marL="0">
+              <a:buNone/>
+            </a:pPr>
+            <a:r>
+              <a:rPr lang="en-US" sz="1100" dirty="0">
+                <a:solidFill>
+                  <a:srgbClr val="9CA3AF"/>
+                </a:solidFill>
+                <a:latin typeface="Calibri" pitchFamily="34" charset="0"/>
+                <a:ea typeface="Calibri" pitchFamily="34" charset="-122"/>
+                <a:cs typeface="Calibri" pitchFamily="34" charset="-120"/>
+              </a:rPr>
+              <a:t>DAO treasury provides pooled bond coverage for qualified workers.</a:t>
+            </a:r>
+            <a:endParaRPr lang="en-US" sz="1100" dirty="0"/>
+          </a:p>
+        </p:txBody>
+      </p:sp>
+      <p:sp>
+        <p:nvSpPr>
+          <p:cNvPr id="21" name="Shape 16"/>
+          <p:cNvSpPr/>
+          <p:nvPr/>
+        </p:nvSpPr>
+        <p:spPr>
+          <a:xfrm>
+            <a:off x="4617720" y="3337560"/>
+            <a:ext cx="4160520" cy="685800"/>
+          </a:xfrm>
+          <a:prstGeom prst="rect">
+            <a:avLst/>
+          </a:prstGeom>
+          <a:solidFill>
+            <a:srgbClr val="374151"/>
+          </a:solidFill>
+          <a:ln w="12700">
+            <a:solidFill>
+              <a:srgbClr val="374151"/>
+            </a:solidFill>
+            <a:prstDash val="solid"/>
+          </a:ln>
+        </p:spPr>
+      </p:sp>
+      <p:sp>
+        <p:nvSpPr>
+          <p:cNvPr id="22" name="Shape 17"/>
+          <p:cNvSpPr/>
+          <p:nvPr/>
+        </p:nvSpPr>
+        <p:spPr>
+          <a:xfrm>
+            <a:off x="4617720" y="3337560"/>
+            <a:ext cx="54864" cy="685800"/>
+          </a:xfrm>
+          <a:prstGeom prst="rect">
+            <a:avLst/>
+          </a:prstGeom>
+          <a:solidFill>
+            <a:srgbClr val="F59E0B"/>
+          </a:solidFill>
+          <a:ln w="12700">
+            <a:solidFill>
+              <a:srgbClr val="F59E0B"/>
+            </a:solidFill>
+            <a:prstDash val="solid"/>
+          </a:ln>
+        </p:spPr>
+      </p:sp>
+      <p:pic>
+        <p:nvPicPr>
+          <p:cNvPr id="23" name="Image 3" descr="preencoded.png">    </p:cNvPr>
+          <p:cNvPicPr>
+            <a:picLocks noChangeAspect="1"/>
+          </p:cNvPicPr>
+          <p:nvPr/>
+        </p:nvPicPr>
+        <p:blipFill>
+          <a:blip r:embed="rId4"/>
+          <a:stretch>
+            <a:fillRect/>
+          </a:stretch>
+        </p:blipFill>
+        <p:spPr>
+          <a:xfrm>
+            <a:off x="4754880" y="3520440"/>
+            <a:ext cx="292608" cy="292608"/>
+          </a:xfrm>
+          <a:prstGeom prst="rect">
+            <a:avLst/>
+          </a:prstGeom>
+        </p:spPr>
+      </p:pic>
+      <p:sp>
+        <p:nvSpPr>
+          <p:cNvPr id="24" name="Text 18"/>
+          <p:cNvSpPr/>
+          <p:nvPr/>
+        </p:nvSpPr>
+        <p:spPr>
+          <a:xfrm>
+            <a:off x="5166360" y="3410712"/>
+            <a:ext cx="3474720" cy="292608"/>
+          </a:xfrm>
+          <a:prstGeom prst="rect">
+            <a:avLst/>
+          </a:prstGeom>
+          <a:noFill/>
+          <a:ln/>
+        </p:spPr>
+        <p:txBody>
+          <a:bodyPr wrap="square" lIns="0" tIns="0" rIns="0" bIns="0" rtlCol="0" anchor="ctr"/>
+          <a:lstStyle/>
+          <a:p>
+            <a:pPr indent="0" marL="0">
+              <a:buNone/>
+            </a:pPr>
+            <a:r>
+              <a:rPr lang="en-US" sz="1300" b="1" dirty="0">
+                <a:solidFill>
+                  <a:srgbClr val="FFFFFF"/>
+                </a:solidFill>
+              </a:rPr>
+              <a:t>M/WBE Certification</a:t>
+            </a:r>
+            <a:endParaRPr lang="en-US" sz="1300" dirty="0"/>
+          </a:p>
+        </p:txBody>
+      </p:sp>
+      <p:sp>
+        <p:nvSpPr>
+          <p:cNvPr id="25" name="Text 19"/>
+          <p:cNvSpPr/>
+          <p:nvPr/>
+        </p:nvSpPr>
+        <p:spPr>
+          <a:xfrm>
+            <a:off x="5166360" y="3721608"/>
+            <a:ext cx="3474720" cy="256032"/>
+          </a:xfrm>
+          <a:prstGeom prst="rect">
+            <a:avLst/>
+          </a:prstGeom>
+          <a:noFill/>
+          <a:ln/>
+        </p:spPr>
+        <p:txBody>
+          <a:bodyPr wrap="square" lIns="0" tIns="0" rIns="0" bIns="0" rtlCol="0" anchor="ctr"/>
+          <a:lstStyle/>
+          <a:p>
+            <a:pPr indent="0" marL="0">
+              <a:buNone/>
+            </a:pPr>
+            <a:r>
+              <a:rPr lang="en-US" sz="1100" dirty="0">
+                <a:solidFill>
+                  <a:srgbClr val="9CA3AF"/>
+                </a:solidFill>
+                <a:latin typeface="Calibri" pitchFamily="34" charset="0"/>
+                <a:ea typeface="Calibri" pitchFamily="34" charset="-122"/>
+                <a:cs typeface="Calibri" pitchFamily="34" charset="-120"/>
+              </a:rPr>
+              <a:t>Recognized as a credential tier. Increases bid weight.</a:t>
+            </a:r>
+            <a:endParaRPr lang="en-US" sz="1100" dirty="0"/>
+          </a:p>
+        </p:txBody>
+      </p:sp>
+      <p:sp>
+        <p:nvSpPr>
+          <p:cNvPr id="26" name="Shape 20"/>
+          <p:cNvSpPr/>
+          <p:nvPr/>
+        </p:nvSpPr>
+        <p:spPr>
+          <a:xfrm>
+            <a:off x="274320" y="4206240"/>
+            <a:ext cx="4160520" cy="685800"/>
+          </a:xfrm>
+          <a:prstGeom prst="rect">
+            <a:avLst/>
+          </a:prstGeom>
+          <a:solidFill>
+            <a:srgbClr val="374151"/>
+          </a:solidFill>
+          <a:ln w="12700">
+            <a:solidFill>
+              <a:srgbClr val="374151"/>
+            </a:solidFill>
+            <a:prstDash val="solid"/>
+          </a:ln>
+        </p:spPr>
+      </p:sp>
+      <p:sp>
+        <p:nvSpPr>
+          <p:cNvPr id="27" name="Shape 21"/>
+          <p:cNvSpPr/>
+          <p:nvPr/>
+        </p:nvSpPr>
+        <p:spPr>
+          <a:xfrm>
+            <a:off x="274320" y="4206240"/>
+            <a:ext cx="54864" cy="685800"/>
+          </a:xfrm>
+          <a:prstGeom prst="rect">
+            <a:avLst/>
+          </a:prstGeom>
+          <a:solidFill>
+            <a:srgbClr val="F59E0B"/>
+          </a:solidFill>
+          <a:ln w="12700">
+            <a:solidFill>
+              <a:srgbClr val="F59E0B"/>
+            </a:solidFill>
+            <a:prstDash val="solid"/>
+          </a:ln>
+        </p:spPr>
+      </p:sp>
+      <p:pic>
+        <p:nvPicPr>
+          <p:cNvPr id="28" name="Image 4" descr="preencoded.png">    </p:cNvPr>
+          <p:cNvPicPr>
+            <a:picLocks noChangeAspect="1"/>
+          </p:cNvPicPr>
+          <p:nvPr/>
+        </p:nvPicPr>
+        <p:blipFill>
+          <a:blip r:embed="rId5"/>
+          <a:stretch>
+            <a:fillRect/>
+          </a:stretch>
+        </p:blipFill>
+        <p:spPr>
+          <a:xfrm>
+            <a:off x="411480" y="4389120"/>
+            <a:ext cx="292608" cy="292608"/>
+          </a:xfrm>
+          <a:prstGeom prst="rect">
+            <a:avLst/>
+          </a:prstGeom>
+        </p:spPr>
+      </p:pic>
+      <p:sp>
+        <p:nvSpPr>
+          <p:cNvPr id="29" name="Text 22"/>
+          <p:cNvSpPr/>
+          <p:nvPr/>
+        </p:nvSpPr>
+        <p:spPr>
+          <a:xfrm>
+            <a:off x="822960" y="4279392"/>
+            <a:ext cx="3474720" cy="292608"/>
+          </a:xfrm>
+          <a:prstGeom prst="rect">
+            <a:avLst/>
+          </a:prstGeom>
+          <a:noFill/>
+          <a:ln/>
+        </p:spPr>
+        <p:txBody>
+          <a:bodyPr wrap="square" lIns="0" tIns="0" rIns="0" bIns="0" rtlCol="0" anchor="ctr"/>
+          <a:lstStyle/>
+          <a:p>
+            <a:pPr indent="0" marL="0">
+              <a:buNone/>
+            </a:pPr>
+            <a:r>
+              <a:rPr lang="en-US" sz="1300" b="1" dirty="0">
+                <a:solidFill>
+                  <a:srgbClr val="FFFFFF"/>
+                </a:solidFill>
+              </a:rPr>
+              <a:t>National Cert Bodies</a:t>
+            </a:r>
+            <a:endParaRPr lang="en-US" sz="1300" dirty="0"/>
+          </a:p>
+        </p:txBody>
+      </p:sp>
+      <p:sp>
+        <p:nvSpPr>
+          <p:cNvPr id="30" name="Text 23"/>
+          <p:cNvSpPr/>
+          <p:nvPr/>
+        </p:nvSpPr>
+        <p:spPr>
+          <a:xfrm>
+            <a:off x="822960" y="4590288"/>
+            <a:ext cx="3474720" cy="256032"/>
+          </a:xfrm>
+          <a:prstGeom prst="rect">
+            <a:avLst/>
+          </a:prstGeom>
+          <a:noFill/>
+          <a:ln/>
+        </p:spPr>
+        <p:txBody>
+          <a:bodyPr wrap="square" lIns="0" tIns="0" rIns="0" bIns="0" rtlCol="0" anchor="ctr"/>
+          <a:lstStyle/>
+          <a:p>
+            <a:pPr indent="0" marL="0">
+              <a:buNone/>
+            </a:pPr>
+            <a:r>
+              <a:rPr lang="en-US" sz="1100" dirty="0">
+                <a:solidFill>
+                  <a:srgbClr val="9CA3AF"/>
+                </a:solidFill>
+                <a:latin typeface="Calibri" pitchFamily="34" charset="0"/>
+                <a:ea typeface="Calibri" pitchFamily="34" charset="-122"/>
+                <a:cs typeface="Calibri" pitchFamily="34" charset="-120"/>
+              </a:rPr>
+              <a:t>HVAC, electrical, plumbing certs → EAS attestation on-chain.</a:t>
+            </a:r>
+            <a:endParaRPr lang="en-US" sz="1100" dirty="0"/>
+          </a:p>
+        </p:txBody>
+      </p:sp>
+      <p:sp>
+        <p:nvSpPr>
+          <p:cNvPr id="31" name="Shape 24"/>
+          <p:cNvSpPr/>
+          <p:nvPr/>
+        </p:nvSpPr>
+        <p:spPr>
+          <a:xfrm>
+            <a:off x="4617720" y="4206240"/>
+            <a:ext cx="4160520" cy="685800"/>
+          </a:xfrm>
+          <a:prstGeom prst="rect">
+            <a:avLst/>
+          </a:prstGeom>
+          <a:solidFill>
+            <a:srgbClr val="374151"/>
+          </a:solidFill>
+          <a:ln w="12700">
+            <a:solidFill>
+              <a:srgbClr val="374151"/>
+            </a:solidFill>
+            <a:prstDash val="solid"/>
+          </a:ln>
+        </p:spPr>
+      </p:sp>
+      <p:sp>
+        <p:nvSpPr>
+          <p:cNvPr id="32" name="Shape 25"/>
+          <p:cNvSpPr/>
+          <p:nvPr/>
+        </p:nvSpPr>
+        <p:spPr>
+          <a:xfrm>
+            <a:off x="4617720" y="4206240"/>
+            <a:ext cx="54864" cy="685800"/>
+          </a:xfrm>
+          <a:prstGeom prst="rect">
+            <a:avLst/>
+          </a:prstGeom>
+          <a:solidFill>
+            <a:srgbClr val="F59E0B"/>
+          </a:solidFill>
+          <a:ln w="12700">
+            <a:solidFill>
+              <a:srgbClr val="F59E0B"/>
+            </a:solidFill>
+            <a:prstDash val="solid"/>
+          </a:ln>
+        </p:spPr>
+      </p:sp>
+      <p:pic>
+        <p:nvPicPr>
+          <p:cNvPr id="33" name="Image 5" descr="preencoded.png">    </p:cNvPr>
+          <p:cNvPicPr>
+            <a:picLocks noChangeAspect="1"/>
+          </p:cNvPicPr>
+          <p:nvPr/>
+        </p:nvPicPr>
+        <p:blipFill>
+          <a:blip r:embed="rId6"/>
+          <a:stretch>
+            <a:fillRect/>
+          </a:stretch>
+        </p:blipFill>
+        <p:spPr>
+          <a:xfrm>
+            <a:off x="4754880" y="4389120"/>
+            <a:ext cx="292608" cy="292608"/>
+          </a:xfrm>
+          <a:prstGeom prst="rect">
+            <a:avLst/>
+          </a:prstGeom>
+        </p:spPr>
+      </p:pic>
+      <p:sp>
+        <p:nvSpPr>
+          <p:cNvPr id="34" name="Text 26"/>
+          <p:cNvSpPr/>
+          <p:nvPr/>
+        </p:nvSpPr>
+        <p:spPr>
+          <a:xfrm>
+            <a:off x="5166360" y="4279392"/>
+            <a:ext cx="3474720" cy="292608"/>
+          </a:xfrm>
+          <a:prstGeom prst="rect">
+            <a:avLst/>
+          </a:prstGeom>
+          <a:noFill/>
+          <a:ln/>
+        </p:spPr>
+        <p:txBody>
+          <a:bodyPr wrap="square" lIns="0" tIns="0" rIns="0" bIns="0" rtlCol="0" anchor="ctr"/>
+          <a:lstStyle/>
+          <a:p>
+            <a:pPr indent="0" marL="0">
+              <a:buNone/>
+            </a:pPr>
+            <a:r>
+              <a:rPr lang="en-US" sz="1300" b="1" dirty="0">
+                <a:solidFill>
+                  <a:srgbClr val="FFFFFF"/>
+                </a:solidFill>
+              </a:rPr>
+              <a:t>Future DAOs &amp; Cities</a:t>
+            </a:r>
+            <a:endParaRPr lang="en-US" sz="1300" dirty="0"/>
+          </a:p>
+        </p:txBody>
+      </p:sp>
+      <p:sp>
+        <p:nvSpPr>
+          <p:cNvPr id="35" name="Text 27"/>
+          <p:cNvSpPr/>
+          <p:nvPr/>
+        </p:nvSpPr>
+        <p:spPr>
+          <a:xfrm>
+            <a:off x="5166360" y="4590288"/>
+            <a:ext cx="3474720" cy="256032"/>
+          </a:xfrm>
+          <a:prstGeom prst="rect">
+            <a:avLst/>
+          </a:prstGeom>
+          <a:noFill/>
+          <a:ln/>
+        </p:spPr>
+        <p:txBody>
+          <a:bodyPr wrap="square" lIns="0" tIns="0" rIns="0" bIns="0" rtlCol="0" anchor="ctr"/>
+          <a:lstStyle/>
+          <a:p>
+            <a:pPr indent="0" marL="0">
+              <a:buNone/>
+            </a:pPr>
+            <a:r>
+              <a:rPr lang="en-US" sz="1100" dirty="0">
+                <a:solidFill>
+                  <a:srgbClr val="9CA3AF"/>
+                </a:solidFill>
+                <a:latin typeface="Calibri" pitchFamily="34" charset="0"/>
+                <a:ea typeface="Calibri" pitchFamily="34" charset="-122"/>
+                <a:cs typeface="Calibri" pitchFamily="34" charset="-120"/>
+              </a:rPr>
+              <a:t>Protocol is open. Any city can deploy their own Guild on top.</a:t>
+            </a:r>
+            <a:endParaRPr lang="en-US" sz="1100" dirty="0"/>
+          </a:p>
+        </p:txBody>
+      </p:sp>
+    </p:spTree>
+  </p:cSld>
+  <p:clrMapOvr>
+    <a:masterClrMapping/>
+  </p:clrMapOvr>
+</p:sld>
+</file>
+
+<file path=ppt/slides/slide11.xml><?xml version="1.0" encoding="utf-8"?>
+<p:sld xmlns:a="http://schemas.openxmlformats.org/drawingml/2006/main" xmlns:r="http://schemas.openxmlformats.org/officeDocument/2006/relationships" xmlns:p="http://schemas.openxmlformats.org/presentationml/2006/main">
+  <p:cSld name="Slide 11">
     <p:bg>
       <p:bgPr>
         <a:solidFill>
@@ -5131,7 +6014,7 @@
                 <a:ea typeface="Calibri" pitchFamily="34" charset="-122"/>
                 <a:cs typeface="Calibri" pitchFamily="34" charset="-120"/>
               </a:rPr>
-              <a:t>Portfolio exists nowhere portable</a:t>
+              <a:t>GitHub shows code — not trust, payment history, or disputes</a:t>
             </a:r>
             <a:endParaRPr lang="en-US" sz="1100" dirty="0"/>
           </a:p>
@@ -9887,7 +10770,7 @@
     <p:bg>
       <p:bgPr>
         <a:solidFill>
-          <a:srgbClr val="1F2937"/>
+          <a:srgbClr val="111827"/>
         </a:solidFill>
       </p:bgPr>
     </p:bg>
@@ -9920,11 +10803,11 @@
             <a:avLst/>
           </a:prstGeom>
           <a:solidFill>
-            <a:srgbClr val="F59E0B"/>
+            <a:srgbClr val="0D9488"/>
           </a:solidFill>
           <a:ln w="12700">
             <a:solidFill>
-              <a:srgbClr val="F59E0B"/>
+              <a:srgbClr val="0D9488"/>
             </a:solidFill>
             <a:prstDash val="solid"/>
           </a:ln>
@@ -9938,8 +10821,8 @@
         </p:nvSpPr>
         <p:spPr>
           <a:xfrm>
-            <a:off x="320040" y="274320"/>
-            <a:ext cx="4572000" cy="320040"/>
+            <a:off x="320040" y="256032"/>
+            <a:ext cx="8229600" cy="320040"/>
           </a:xfrm>
           <a:prstGeom prst="rect">
             <a:avLst/>
@@ -9957,10 +10840,10 @@
             <a:r>
               <a:rPr lang="en-US" sz="1100" b="1" spc="400" kern="0" dirty="0">
                 <a:solidFill>
-                  <a:srgbClr val="F59E0B"/>
-                </a:solidFill>
-              </a:rPr>
-              <a:t>INTEGRATION</a:t>
+                  <a:srgbClr val="0D9488"/>
+                </a:solidFill>
+              </a:rPr>
+              <a:t>UNDER THE HOOD</a:t>
             </a:r>
             <a:endParaRPr lang="en-US" sz="1100" dirty="0"/>
           </a:p>
@@ -9974,27 +10857,24 @@
         </p:nvSpPr>
         <p:spPr>
           <a:xfrm>
-            <a:off x="320040" y="640080"/>
-            <a:ext cx="8503920" cy="1234440"/>
-          </a:xfrm>
-          <a:prstGeom prst="rect">
-            <a:avLst/>
-          </a:prstGeom>
-          <a:noFill/>
-          <a:ln/>
-        </p:spPr>
-        <p:txBody>
-          <a:bodyPr wrap="square" lIns="0" tIns="0" rIns="0" bIns="0" rtlCol="0" anchor="ctr"/>
-          <a:lstStyle/>
-          <a:p>
-            <a:pPr indent="0" marL="0">
-              <a:lnSpc>
-                <a:spcPct val="110000"/>
-              </a:lnSpc>
-              <a:buNone/>
-            </a:pPr>
-            <a:r>
-              <a:rPr lang="en-US" sz="4400" b="1" dirty="0">
+            <a:off x="320040" y="594360"/>
+            <a:ext cx="8503920" cy="548640"/>
+          </a:xfrm>
+          <a:prstGeom prst="rect">
+            <a:avLst/>
+          </a:prstGeom>
+          <a:noFill/>
+          <a:ln/>
+        </p:spPr>
+        <p:txBody>
+          <a:bodyPr wrap="square" lIns="0" tIns="0" rIns="0" bIns="0" rtlCol="0" anchor="ctr"/>
+          <a:lstStyle/>
+          <a:p>
+            <a:pPr indent="0" marL="0">
+              <a:buNone/>
+            </a:pPr>
+            <a:r>
+              <a:rPr lang="en-US" sz="2600" b="1" dirty="0">
                 <a:solidFill>
                   <a:srgbClr val="FFFFFF"/>
                 </a:solidFill>
@@ -10002,85 +10882,27 @@
                 <a:ea typeface="Arial Black" pitchFamily="34" charset="-122"/>
                 <a:cs typeface="Arial Black" pitchFamily="34" charset="-120"/>
               </a:rPr>
-              <a:t>Works with what</a:t>
-            </a:r>
-            <a:endParaRPr lang="en-US" sz="4400" dirty="0"/>
-          </a:p>
-          <a:p>
-            <a:pPr indent="0" marL="0">
-              <a:lnSpc>
-                <a:spcPct val="110000"/>
-              </a:lnSpc>
-              <a:buNone/>
-            </a:pPr>
-            <a:r>
-              <a:rPr lang="en-US" sz="4400" b="1" dirty="0">
-                <a:solidFill>
-                  <a:srgbClr val="FFFFFF"/>
-                </a:solidFill>
-                <a:latin typeface="Arial Black" pitchFamily="34" charset="0"/>
-                <a:ea typeface="Arial Black" pitchFamily="34" charset="-122"/>
-                <a:cs typeface="Arial Black" pitchFamily="34" charset="-120"/>
-              </a:rPr>
-              <a:t>already exists.</a:t>
-            </a:r>
-            <a:endParaRPr lang="en-US" sz="4400" dirty="0"/>
-          </a:p>
-        </p:txBody>
-      </p:sp>
-      <p:sp>
-        <p:nvSpPr>
-          <p:cNvPr id="5" name="Text 3"/>
-          <p:cNvSpPr/>
-          <p:nvPr/>
-        </p:nvSpPr>
-        <p:spPr>
-          <a:xfrm>
-            <a:off x="320040" y="1920240"/>
-            <a:ext cx="8503920" cy="365760"/>
-          </a:xfrm>
-          <a:prstGeom prst="rect">
-            <a:avLst/>
-          </a:prstGeom>
-          <a:noFill/>
-          <a:ln/>
-        </p:spPr>
-        <p:txBody>
-          <a:bodyPr wrap="square" lIns="0" tIns="0" rIns="0" bIns="0" rtlCol="0" anchor="ctr"/>
-          <a:lstStyle/>
-          <a:p>
-            <a:pPr indent="0" marL="0">
-              <a:buNone/>
-            </a:pPr>
-            <a:r>
-              <a:rPr lang="en-US" sz="1500" i="1" dirty="0">
-                <a:solidFill>
-                  <a:srgbClr val="9CA3AF"/>
-                </a:solidFill>
-              </a:rPr>
-              <a:t>We don't replace licensing. We make it navigable and portable.</a:t>
-            </a:r>
-            <a:endParaRPr lang="en-US" sz="1500" dirty="0"/>
-          </a:p>
-        </p:txBody>
-      </p:sp>
-      <p:sp>
-        <p:nvSpPr>
-          <p:cNvPr id="6" name="Shape 4"/>
-          <p:cNvSpPr/>
-          <p:nvPr/>
-        </p:nvSpPr>
-        <p:spPr>
-          <a:xfrm>
-            <a:off x="274320" y="2468880"/>
-            <a:ext cx="4160520" cy="685800"/>
-          </a:xfrm>
-          <a:prstGeom prst="rect">
-            <a:avLst/>
-          </a:prstGeom>
-          <a:solidFill>
-            <a:srgbClr val="374151"/>
-          </a:solidFill>
+              <a:t>What's shipping now — and what's coming.</a:t>
+            </a:r>
+            <a:endParaRPr lang="en-US" sz="2600" dirty="0"/>
+          </a:p>
+        </p:txBody>
+      </p:sp>
+      <p:sp>
+        <p:nvSpPr>
+          <p:cNvPr id="5" name="Shape 3"/>
+          <p:cNvSpPr/>
+          <p:nvPr/>
+        </p:nvSpPr>
+        <p:spPr>
+          <a:xfrm>
+            <a:off x="4617720" y="1280160"/>
+            <a:ext cx="0" cy="3566160"/>
+          </a:xfrm>
+          <a:prstGeom prst="line">
+            <a:avLst/>
+          </a:prstGeom>
+          <a:noFill/>
           <a:ln w="12700">
             <a:solidFill>
               <a:srgbClr val="374151"/>
@@ -10091,144 +10913,81 @@
       </p:sp>
       <p:sp>
         <p:nvSpPr>
-          <p:cNvPr id="7" name="Shape 5"/>
-          <p:cNvSpPr/>
-          <p:nvPr/>
-        </p:nvSpPr>
-        <p:spPr>
-          <a:xfrm>
-            <a:off x="274320" y="2468880"/>
-            <a:ext cx="54864" cy="685800"/>
-          </a:xfrm>
-          <a:prstGeom prst="rect">
-            <a:avLst/>
-          </a:prstGeom>
-          <a:solidFill>
-            <a:srgbClr val="F59E0B"/>
+          <p:cNvPr id="6" name="Shape 4"/>
+          <p:cNvSpPr/>
+          <p:nvPr/>
+        </p:nvSpPr>
+        <p:spPr>
+          <a:xfrm>
+            <a:off x="320040" y="1261872"/>
+            <a:ext cx="1554480" cy="329184"/>
+          </a:xfrm>
+          <a:prstGeom prst="rect">
+            <a:avLst/>
+          </a:prstGeom>
+          <a:solidFill>
+            <a:srgbClr val="0D9488"/>
           </a:solidFill>
           <a:ln w="12700">
             <a:solidFill>
-              <a:srgbClr val="F59E0B"/>
+              <a:srgbClr val="0D9488"/>
             </a:solidFill>
             <a:prstDash val="solid"/>
           </a:ln>
         </p:spPr>
       </p:sp>
-      <p:pic>
-        <p:nvPicPr>
-          <p:cNvPr id="8" name="Image 0" descr="preencoded.png">    </p:cNvPr>
-          <p:cNvPicPr>
-            <a:picLocks noChangeAspect="1"/>
-          </p:cNvPicPr>
-          <p:nvPr/>
-        </p:nvPicPr>
-        <p:blipFill>
-          <a:blip r:embed="rId1"/>
-          <a:stretch>
-            <a:fillRect/>
-          </a:stretch>
-        </p:blipFill>
-        <p:spPr>
-          <a:xfrm>
-            <a:off x="411480" y="2651760"/>
-            <a:ext cx="292608" cy="292608"/>
-          </a:xfrm>
-          <a:prstGeom prst="rect">
-            <a:avLst/>
-          </a:prstGeom>
-        </p:spPr>
-      </p:pic>
-      <p:sp>
-        <p:nvSpPr>
-          <p:cNvPr id="9" name="Text 6"/>
-          <p:cNvSpPr/>
-          <p:nvPr/>
-        </p:nvSpPr>
-        <p:spPr>
-          <a:xfrm>
-            <a:off x="822960" y="2542032"/>
-            <a:ext cx="3474720" cy="292608"/>
-          </a:xfrm>
-          <a:prstGeom prst="rect">
-            <a:avLst/>
-          </a:prstGeom>
-          <a:noFill/>
-          <a:ln/>
-        </p:spPr>
-        <p:txBody>
-          <a:bodyPr wrap="square" lIns="0" tIns="0" rIns="0" bIns="0" rtlCol="0" anchor="ctr"/>
-          <a:lstStyle/>
-          <a:p>
-            <a:pPr indent="0" marL="0">
-              <a:buNone/>
-            </a:pPr>
-            <a:r>
-              <a:rPr lang="en-US" sz="1300" b="1" dirty="0">
-                <a:solidFill>
-                  <a:srgbClr val="FFFFFF"/>
-                </a:solidFill>
-              </a:rPr>
-              <a:t>TDLR Licenses</a:t>
-            </a:r>
-            <a:endParaRPr lang="en-US" sz="1300" dirty="0"/>
-          </a:p>
-        </p:txBody>
-      </p:sp>
-      <p:sp>
-        <p:nvSpPr>
-          <p:cNvPr id="10" name="Text 7"/>
-          <p:cNvSpPr/>
-          <p:nvPr/>
-        </p:nvSpPr>
-        <p:spPr>
-          <a:xfrm>
-            <a:off x="822960" y="2852928"/>
-            <a:ext cx="3474720" cy="256032"/>
-          </a:xfrm>
-          <a:prstGeom prst="rect">
-            <a:avLst/>
-          </a:prstGeom>
-          <a:noFill/>
-          <a:ln/>
-        </p:spPr>
-        <p:txBody>
-          <a:bodyPr wrap="square" lIns="0" tIns="0" rIns="0" bIns="0" rtlCol="0" anchor="ctr"/>
-          <a:lstStyle/>
-          <a:p>
-            <a:pPr indent="0" marL="0">
-              <a:buNone/>
-            </a:pPr>
-            <a:r>
-              <a:rPr lang="en-US" sz="1100" dirty="0">
-                <a:solidFill>
-                  <a:srgbClr val="9CA3AF"/>
-                </a:solidFill>
-                <a:latin typeface="Calibri" pitchFamily="34" charset="0"/>
-                <a:ea typeface="Calibri" pitchFamily="34" charset="-122"/>
-                <a:cs typeface="Calibri" pitchFamily="34" charset="-120"/>
-              </a:rPr>
-              <a:t>Verified on-chain via API. Worker-owned attestation.</a:t>
-            </a:r>
-            <a:endParaRPr lang="en-US" sz="1100" dirty="0"/>
-          </a:p>
-        </p:txBody>
-      </p:sp>
-      <p:sp>
-        <p:nvSpPr>
-          <p:cNvPr id="11" name="Shape 8"/>
-          <p:cNvSpPr/>
-          <p:nvPr/>
-        </p:nvSpPr>
-        <p:spPr>
-          <a:xfrm>
-            <a:off x="4617720" y="2468880"/>
-            <a:ext cx="4160520" cy="685800"/>
-          </a:xfrm>
-          <a:prstGeom prst="rect">
-            <a:avLst/>
-          </a:prstGeom>
-          <a:solidFill>
-            <a:srgbClr val="374151"/>
+      <p:sp>
+        <p:nvSpPr>
+          <p:cNvPr id="7" name="Text 5"/>
+          <p:cNvSpPr/>
+          <p:nvPr/>
+        </p:nvSpPr>
+        <p:spPr>
+          <a:xfrm>
+            <a:off x="320040" y="1261872"/>
+            <a:ext cx="1554480" cy="329184"/>
+          </a:xfrm>
+          <a:prstGeom prst="rect">
+            <a:avLst/>
+          </a:prstGeom>
+          <a:noFill/>
+          <a:ln/>
+        </p:spPr>
+        <p:txBody>
+          <a:bodyPr wrap="square" lIns="0" tIns="0" rIns="0" bIns="0" rtlCol="0" anchor="ctr"/>
+          <a:lstStyle/>
+          <a:p>
+            <a:pPr algn="ctr" indent="0" marL="0">
+              <a:buNone/>
+            </a:pPr>
+            <a:r>
+              <a:rPr lang="en-US" sz="1000" b="1" spc="100" kern="0" dirty="0">
+                <a:solidFill>
+                  <a:srgbClr val="111827"/>
+                </a:solidFill>
+              </a:rPr>
+              <a:t>LIVE / IN BUILD</a:t>
+            </a:r>
+            <a:endParaRPr lang="en-US" sz="1000" dirty="0"/>
+          </a:p>
+        </p:txBody>
+      </p:sp>
+      <p:sp>
+        <p:nvSpPr>
+          <p:cNvPr id="8" name="Shape 6"/>
+          <p:cNvSpPr/>
+          <p:nvPr/>
+        </p:nvSpPr>
+        <p:spPr>
+          <a:xfrm>
+            <a:off x="320040" y="1691640"/>
+            <a:ext cx="4114800" cy="621792"/>
+          </a:xfrm>
+          <a:prstGeom prst="rect">
+            <a:avLst/>
+          </a:prstGeom>
+          <a:solidFill>
+            <a:srgbClr val="1F2937"/>
           </a:solidFill>
           <a:ln w="12700">
             <a:solidFill>
@@ -10240,115 +10999,91 @@
       </p:sp>
       <p:sp>
         <p:nvSpPr>
-          <p:cNvPr id="12" name="Shape 9"/>
-          <p:cNvSpPr/>
-          <p:nvPr/>
-        </p:nvSpPr>
-        <p:spPr>
-          <a:xfrm>
-            <a:off x="4617720" y="2468880"/>
-            <a:ext cx="54864" cy="685800"/>
-          </a:xfrm>
-          <a:prstGeom prst="rect">
-            <a:avLst/>
-          </a:prstGeom>
-          <a:solidFill>
-            <a:srgbClr val="F59E0B"/>
+          <p:cNvPr id="9" name="Shape 7"/>
+          <p:cNvSpPr/>
+          <p:nvPr/>
+        </p:nvSpPr>
+        <p:spPr>
+          <a:xfrm>
+            <a:off x="384048" y="1847088"/>
+            <a:ext cx="292608" cy="292608"/>
+          </a:xfrm>
+          <a:prstGeom prst="ellipse">
+            <a:avLst/>
+          </a:prstGeom>
+          <a:solidFill>
+            <a:srgbClr val="0D9488"/>
           </a:solidFill>
           <a:ln w="12700">
             <a:solidFill>
-              <a:srgbClr val="F59E0B"/>
+              <a:srgbClr val="0D9488"/>
             </a:solidFill>
             <a:prstDash val="solid"/>
           </a:ln>
         </p:spPr>
       </p:sp>
-      <p:pic>
-        <p:nvPicPr>
-          <p:cNvPr id="13" name="Image 1" descr="preencoded.png">    </p:cNvPr>
-          <p:cNvPicPr>
-            <a:picLocks noChangeAspect="1"/>
-          </p:cNvPicPr>
-          <p:nvPr/>
-        </p:nvPicPr>
-        <p:blipFill>
-          <a:blip r:embed="rId2"/>
-          <a:stretch>
-            <a:fillRect/>
-          </a:stretch>
-        </p:blipFill>
-        <p:spPr>
-          <a:xfrm>
-            <a:off x="4754880" y="2651760"/>
-            <a:ext cx="292608" cy="292608"/>
-          </a:xfrm>
-          <a:prstGeom prst="rect">
-            <a:avLst/>
-          </a:prstGeom>
-        </p:spPr>
-      </p:pic>
-      <p:sp>
-        <p:nvSpPr>
-          <p:cNvPr id="14" name="Text 10"/>
-          <p:cNvSpPr/>
-          <p:nvPr/>
-        </p:nvSpPr>
-        <p:spPr>
-          <a:xfrm>
-            <a:off x="5166360" y="2542032"/>
-            <a:ext cx="3474720" cy="292608"/>
-          </a:xfrm>
-          <a:prstGeom prst="rect">
-            <a:avLst/>
-          </a:prstGeom>
-          <a:noFill/>
-          <a:ln/>
-        </p:spPr>
-        <p:txBody>
-          <a:bodyPr wrap="square" lIns="0" tIns="0" rIns="0" bIns="0" rtlCol="0" anchor="ctr"/>
-          <a:lstStyle/>
-          <a:p>
-            <a:pPr indent="0" marL="0">
-              <a:buNone/>
-            </a:pPr>
-            <a:r>
-              <a:rPr lang="en-US" sz="1300" b="1" dirty="0">
-                <a:solidFill>
-                  <a:srgbClr val="FFFFFF"/>
-                </a:solidFill>
-              </a:rPr>
-              <a:t>Bonfire Procurement</a:t>
-            </a:r>
-            <a:endParaRPr lang="en-US" sz="1300" dirty="0"/>
-          </a:p>
-        </p:txBody>
-      </p:sp>
-      <p:sp>
-        <p:nvSpPr>
-          <p:cNvPr id="15" name="Text 11"/>
-          <p:cNvSpPr/>
-          <p:nvPr/>
-        </p:nvSpPr>
-        <p:spPr>
-          <a:xfrm>
-            <a:off x="5166360" y="2852928"/>
-            <a:ext cx="3474720" cy="256032"/>
-          </a:xfrm>
-          <a:prstGeom prst="rect">
-            <a:avLst/>
-          </a:prstGeom>
-          <a:noFill/>
-          <a:ln/>
-        </p:spPr>
-        <p:txBody>
-          <a:bodyPr wrap="square" lIns="0" tIns="0" rIns="0" bIns="0" rtlCol="0" anchor="ctr"/>
-          <a:lstStyle/>
-          <a:p>
-            <a:pPr indent="0" marL="0">
-              <a:buNone/>
-            </a:pPr>
-            <a:r>
-              <a:rPr lang="en-US" sz="1100" dirty="0">
+      <p:sp>
+        <p:nvSpPr>
+          <p:cNvPr id="10" name="Text 8"/>
+          <p:cNvSpPr/>
+          <p:nvPr/>
+        </p:nvSpPr>
+        <p:spPr>
+          <a:xfrm>
+            <a:off x="777240" y="1746504"/>
+            <a:ext cx="1371600" cy="256032"/>
+          </a:xfrm>
+          <a:prstGeom prst="rect">
+            <a:avLst/>
+          </a:prstGeom>
+          <a:noFill/>
+          <a:ln/>
+        </p:spPr>
+        <p:txBody>
+          <a:bodyPr wrap="square" lIns="0" tIns="0" rIns="0" bIns="0" rtlCol="0" anchor="ctr"/>
+          <a:lstStyle/>
+          <a:p>
+            <a:pPr indent="0" marL="0">
+              <a:buNone/>
+            </a:pPr>
+            <a:r>
+              <a:rPr lang="en-US" sz="1200" b="1" dirty="0">
+                <a:solidFill>
+                  <a:srgbClr val="FCD34D"/>
+                </a:solidFill>
+              </a:rPr>
+              <a:t>BASE</a:t>
+            </a:r>
+            <a:endParaRPr lang="en-US" sz="1200" dirty="0"/>
+          </a:p>
+        </p:txBody>
+      </p:sp>
+      <p:sp>
+        <p:nvSpPr>
+          <p:cNvPr id="11" name="Text 9"/>
+          <p:cNvSpPr/>
+          <p:nvPr/>
+        </p:nvSpPr>
+        <p:spPr>
+          <a:xfrm>
+            <a:off x="777240" y="2002536"/>
+            <a:ext cx="3520440" cy="256032"/>
+          </a:xfrm>
+          <a:prstGeom prst="rect">
+            <a:avLst/>
+          </a:prstGeom>
+          <a:noFill/>
+          <a:ln/>
+        </p:spPr>
+        <p:txBody>
+          <a:bodyPr wrap="square" lIns="0" tIns="0" rIns="0" bIns="0" rtlCol="0" anchor="ctr"/>
+          <a:lstStyle/>
+          <a:p>
+            <a:pPr indent="0" marL="0">
+              <a:buNone/>
+            </a:pPr>
+            <a:r>
+              <a:rPr lang="en-US" sz="1000" dirty="0">
                 <a:solidFill>
                   <a:srgbClr val="9CA3AF"/>
                 </a:solidFill>
@@ -10356,28 +11091,28 @@
                 <a:ea typeface="Calibri" pitchFamily="34" charset="-122"/>
                 <a:cs typeface="Calibri" pitchFamily="34" charset="-120"/>
               </a:rPr>
-              <a:t>Scout agent monitors RFPs. Workers get alerts before the deadline.</a:t>
-            </a:r>
-            <a:endParaRPr lang="en-US" sz="1100" dirty="0"/>
-          </a:p>
-        </p:txBody>
-      </p:sp>
-      <p:sp>
-        <p:nvSpPr>
-          <p:cNvPr id="16" name="Shape 12"/>
-          <p:cNvSpPr/>
-          <p:nvPr/>
-        </p:nvSpPr>
-        <p:spPr>
-          <a:xfrm>
-            <a:off x="274320" y="3337560"/>
-            <a:ext cx="4160520" cy="685800"/>
-          </a:xfrm>
-          <a:prstGeom prst="rect">
-            <a:avLst/>
-          </a:prstGeom>
-          <a:solidFill>
-            <a:srgbClr val="374151"/>
+              <a:t>Layer 2 on Ethereum — low fees, fast finality, EVM-compatible smart contracts</a:t>
+            </a:r>
+            <a:endParaRPr lang="en-US" sz="1000" dirty="0"/>
+          </a:p>
+        </p:txBody>
+      </p:sp>
+      <p:sp>
+        <p:nvSpPr>
+          <p:cNvPr id="12" name="Shape 10"/>
+          <p:cNvSpPr/>
+          <p:nvPr/>
+        </p:nvSpPr>
+        <p:spPr>
+          <a:xfrm>
+            <a:off x="320040" y="2386584"/>
+            <a:ext cx="4114800" cy="621792"/>
+          </a:xfrm>
+          <a:prstGeom prst="rect">
+            <a:avLst/>
+          </a:prstGeom>
+          <a:solidFill>
+            <a:srgbClr val="1F2937"/>
           </a:solidFill>
           <a:ln w="12700">
             <a:solidFill>
@@ -10389,115 +11124,91 @@
       </p:sp>
       <p:sp>
         <p:nvSpPr>
-          <p:cNvPr id="17" name="Shape 13"/>
-          <p:cNvSpPr/>
-          <p:nvPr/>
-        </p:nvSpPr>
-        <p:spPr>
-          <a:xfrm>
-            <a:off x="274320" y="3337560"/>
-            <a:ext cx="54864" cy="685800"/>
-          </a:xfrm>
-          <a:prstGeom prst="rect">
-            <a:avLst/>
-          </a:prstGeom>
-          <a:solidFill>
-            <a:srgbClr val="F59E0B"/>
+          <p:cNvPr id="13" name="Shape 11"/>
+          <p:cNvSpPr/>
+          <p:nvPr/>
+        </p:nvSpPr>
+        <p:spPr>
+          <a:xfrm>
+            <a:off x="384048" y="2542032"/>
+            <a:ext cx="292608" cy="292608"/>
+          </a:xfrm>
+          <a:prstGeom prst="ellipse">
+            <a:avLst/>
+          </a:prstGeom>
+          <a:solidFill>
+            <a:srgbClr val="0D9488"/>
           </a:solidFill>
           <a:ln w="12700">
             <a:solidFill>
-              <a:srgbClr val="F59E0B"/>
+              <a:srgbClr val="0D9488"/>
             </a:solidFill>
             <a:prstDash val="solid"/>
           </a:ln>
         </p:spPr>
       </p:sp>
-      <p:pic>
-        <p:nvPicPr>
-          <p:cNvPr id="18" name="Image 2" descr="preencoded.png">    </p:cNvPr>
-          <p:cNvPicPr>
-            <a:picLocks noChangeAspect="1"/>
-          </p:cNvPicPr>
-          <p:nvPr/>
-        </p:nvPicPr>
-        <p:blipFill>
-          <a:blip r:embed="rId3"/>
-          <a:stretch>
-            <a:fillRect/>
-          </a:stretch>
-        </p:blipFill>
-        <p:spPr>
-          <a:xfrm>
-            <a:off x="411480" y="3520440"/>
-            <a:ext cx="292608" cy="292608"/>
-          </a:xfrm>
-          <a:prstGeom prst="rect">
-            <a:avLst/>
-          </a:prstGeom>
-        </p:spPr>
-      </p:pic>
-      <p:sp>
-        <p:nvSpPr>
-          <p:cNvPr id="19" name="Text 14"/>
-          <p:cNvSpPr/>
-          <p:nvPr/>
-        </p:nvSpPr>
-        <p:spPr>
-          <a:xfrm>
-            <a:off x="822960" y="3410712"/>
-            <a:ext cx="3474720" cy="292608"/>
-          </a:xfrm>
-          <a:prstGeom prst="rect">
-            <a:avLst/>
-          </a:prstGeom>
-          <a:noFill/>
-          <a:ln/>
-        </p:spPr>
-        <p:txBody>
-          <a:bodyPr wrap="square" lIns="0" tIns="0" rIns="0" bIns="0" rtlCol="0" anchor="ctr"/>
-          <a:lstStyle/>
-          <a:p>
-            <a:pPr indent="0" marL="0">
-              <a:buNone/>
-            </a:pPr>
-            <a:r>
-              <a:rPr lang="en-US" sz="1300" b="1" dirty="0">
-                <a:solidFill>
-                  <a:srgbClr val="FFFFFF"/>
-                </a:solidFill>
-              </a:rPr>
-              <a:t>City Bond Programs</a:t>
-            </a:r>
-            <a:endParaRPr lang="en-US" sz="1300" dirty="0"/>
-          </a:p>
-        </p:txBody>
-      </p:sp>
-      <p:sp>
-        <p:nvSpPr>
-          <p:cNvPr id="20" name="Text 15"/>
-          <p:cNvSpPr/>
-          <p:nvPr/>
-        </p:nvSpPr>
-        <p:spPr>
-          <a:xfrm>
-            <a:off x="822960" y="3721608"/>
-            <a:ext cx="3474720" cy="256032"/>
-          </a:xfrm>
-          <a:prstGeom prst="rect">
-            <a:avLst/>
-          </a:prstGeom>
-          <a:noFill/>
-          <a:ln/>
-        </p:spPr>
-        <p:txBody>
-          <a:bodyPr wrap="square" lIns="0" tIns="0" rIns="0" bIns="0" rtlCol="0" anchor="ctr"/>
-          <a:lstStyle/>
-          <a:p>
-            <a:pPr indent="0" marL="0">
-              <a:buNone/>
-            </a:pPr>
-            <a:r>
-              <a:rPr lang="en-US" sz="1100" dirty="0">
+      <p:sp>
+        <p:nvSpPr>
+          <p:cNvPr id="14" name="Text 12"/>
+          <p:cNvSpPr/>
+          <p:nvPr/>
+        </p:nvSpPr>
+        <p:spPr>
+          <a:xfrm>
+            <a:off x="777240" y="2441448"/>
+            <a:ext cx="1371600" cy="256032"/>
+          </a:xfrm>
+          <a:prstGeom prst="rect">
+            <a:avLst/>
+          </a:prstGeom>
+          <a:noFill/>
+          <a:ln/>
+        </p:spPr>
+        <p:txBody>
+          <a:bodyPr wrap="square" lIns="0" tIns="0" rIns="0" bIns="0" rtlCol="0" anchor="ctr"/>
+          <a:lstStyle/>
+          <a:p>
+            <a:pPr indent="0" marL="0">
+              <a:buNone/>
+            </a:pPr>
+            <a:r>
+              <a:rPr lang="en-US" sz="1200" b="1" dirty="0">
+                <a:solidFill>
+                  <a:srgbClr val="FCD34D"/>
+                </a:solidFill>
+              </a:rPr>
+              <a:t>EAS</a:t>
+            </a:r>
+            <a:endParaRPr lang="en-US" sz="1200" dirty="0"/>
+          </a:p>
+        </p:txBody>
+      </p:sp>
+      <p:sp>
+        <p:nvSpPr>
+          <p:cNvPr id="15" name="Text 13"/>
+          <p:cNvSpPr/>
+          <p:nvPr/>
+        </p:nvSpPr>
+        <p:spPr>
+          <a:xfrm>
+            <a:off x="777240" y="2697480"/>
+            <a:ext cx="3520440" cy="256032"/>
+          </a:xfrm>
+          <a:prstGeom prst="rect">
+            <a:avLst/>
+          </a:prstGeom>
+          <a:noFill/>
+          <a:ln/>
+        </p:spPr>
+        <p:txBody>
+          <a:bodyPr wrap="square" lIns="0" tIns="0" rIns="0" bIns="0" rtlCol="0" anchor="ctr"/>
+          <a:lstStyle/>
+          <a:p>
+            <a:pPr indent="0" marL="0">
+              <a:buNone/>
+            </a:pPr>
+            <a:r>
+              <a:rPr lang="en-US" sz="1000" dirty="0">
                 <a:solidFill>
                   <a:srgbClr val="9CA3AF"/>
                 </a:solidFill>
@@ -10505,28 +11216,28 @@
                 <a:ea typeface="Calibri" pitchFamily="34" charset="-122"/>
                 <a:cs typeface="Calibri" pitchFamily="34" charset="-120"/>
               </a:rPr>
-              <a:t>DAO treasury provides pooled bond coverage for qualified workers.</a:t>
-            </a:r>
-            <a:endParaRPr lang="en-US" sz="1100" dirty="0"/>
-          </a:p>
-        </p:txBody>
-      </p:sp>
-      <p:sp>
-        <p:nvSpPr>
-          <p:cNvPr id="21" name="Shape 16"/>
-          <p:cNvSpPr/>
-          <p:nvPr/>
-        </p:nvSpPr>
-        <p:spPr>
-          <a:xfrm>
-            <a:off x="4617720" y="3337560"/>
-            <a:ext cx="4160520" cy="685800"/>
-          </a:xfrm>
-          <a:prstGeom prst="rect">
-            <a:avLst/>
-          </a:prstGeom>
-          <a:solidFill>
-            <a:srgbClr val="374151"/>
+              <a:t>Ethereum Attestation Service — on-chain credentials workers own forever</a:t>
+            </a:r>
+            <a:endParaRPr lang="en-US" sz="1000" dirty="0"/>
+          </a:p>
+        </p:txBody>
+      </p:sp>
+      <p:sp>
+        <p:nvSpPr>
+          <p:cNvPr id="16" name="Shape 14"/>
+          <p:cNvSpPr/>
+          <p:nvPr/>
+        </p:nvSpPr>
+        <p:spPr>
+          <a:xfrm>
+            <a:off x="320040" y="3081528"/>
+            <a:ext cx="4114800" cy="621792"/>
+          </a:xfrm>
+          <a:prstGeom prst="rect">
+            <a:avLst/>
+          </a:prstGeom>
+          <a:solidFill>
+            <a:srgbClr val="1F2937"/>
           </a:solidFill>
           <a:ln w="12700">
             <a:solidFill>
@@ -10538,115 +11249,91 @@
       </p:sp>
       <p:sp>
         <p:nvSpPr>
-          <p:cNvPr id="22" name="Shape 17"/>
-          <p:cNvSpPr/>
-          <p:nvPr/>
-        </p:nvSpPr>
-        <p:spPr>
-          <a:xfrm>
-            <a:off x="4617720" y="3337560"/>
-            <a:ext cx="54864" cy="685800"/>
-          </a:xfrm>
-          <a:prstGeom prst="rect">
-            <a:avLst/>
-          </a:prstGeom>
-          <a:solidFill>
-            <a:srgbClr val="F59E0B"/>
+          <p:cNvPr id="17" name="Shape 15"/>
+          <p:cNvSpPr/>
+          <p:nvPr/>
+        </p:nvSpPr>
+        <p:spPr>
+          <a:xfrm>
+            <a:off x="384048" y="3236976"/>
+            <a:ext cx="292608" cy="292608"/>
+          </a:xfrm>
+          <a:prstGeom prst="ellipse">
+            <a:avLst/>
+          </a:prstGeom>
+          <a:solidFill>
+            <a:srgbClr val="0D9488"/>
           </a:solidFill>
           <a:ln w="12700">
             <a:solidFill>
-              <a:srgbClr val="F59E0B"/>
+              <a:srgbClr val="0D9488"/>
             </a:solidFill>
             <a:prstDash val="solid"/>
           </a:ln>
         </p:spPr>
       </p:sp>
-      <p:pic>
-        <p:nvPicPr>
-          <p:cNvPr id="23" name="Image 3" descr="preencoded.png">    </p:cNvPr>
-          <p:cNvPicPr>
-            <a:picLocks noChangeAspect="1"/>
-          </p:cNvPicPr>
-          <p:nvPr/>
-        </p:nvPicPr>
-        <p:blipFill>
-          <a:blip r:embed="rId4"/>
-          <a:stretch>
-            <a:fillRect/>
-          </a:stretch>
-        </p:blipFill>
-        <p:spPr>
-          <a:xfrm>
-            <a:off x="4754880" y="3520440"/>
-            <a:ext cx="292608" cy="292608"/>
-          </a:xfrm>
-          <a:prstGeom prst="rect">
-            <a:avLst/>
-          </a:prstGeom>
-        </p:spPr>
-      </p:pic>
-      <p:sp>
-        <p:nvSpPr>
-          <p:cNvPr id="24" name="Text 18"/>
-          <p:cNvSpPr/>
-          <p:nvPr/>
-        </p:nvSpPr>
-        <p:spPr>
-          <a:xfrm>
-            <a:off x="5166360" y="3410712"/>
-            <a:ext cx="3474720" cy="292608"/>
-          </a:xfrm>
-          <a:prstGeom prst="rect">
-            <a:avLst/>
-          </a:prstGeom>
-          <a:noFill/>
-          <a:ln/>
-        </p:spPr>
-        <p:txBody>
-          <a:bodyPr wrap="square" lIns="0" tIns="0" rIns="0" bIns="0" rtlCol="0" anchor="ctr"/>
-          <a:lstStyle/>
-          <a:p>
-            <a:pPr indent="0" marL="0">
-              <a:buNone/>
-            </a:pPr>
-            <a:r>
-              <a:rPr lang="en-US" sz="1300" b="1" dirty="0">
-                <a:solidFill>
-                  <a:srgbClr val="FFFFFF"/>
-                </a:solidFill>
-              </a:rPr>
-              <a:t>M/WBE Certification</a:t>
-            </a:r>
-            <a:endParaRPr lang="en-US" sz="1300" dirty="0"/>
-          </a:p>
-        </p:txBody>
-      </p:sp>
-      <p:sp>
-        <p:nvSpPr>
-          <p:cNvPr id="25" name="Text 19"/>
-          <p:cNvSpPr/>
-          <p:nvPr/>
-        </p:nvSpPr>
-        <p:spPr>
-          <a:xfrm>
-            <a:off x="5166360" y="3721608"/>
-            <a:ext cx="3474720" cy="256032"/>
-          </a:xfrm>
-          <a:prstGeom prst="rect">
-            <a:avLst/>
-          </a:prstGeom>
-          <a:noFill/>
-          <a:ln/>
-        </p:spPr>
-        <p:txBody>
-          <a:bodyPr wrap="square" lIns="0" tIns="0" rIns="0" bIns="0" rtlCol="0" anchor="ctr"/>
-          <a:lstStyle/>
-          <a:p>
-            <a:pPr indent="0" marL="0">
-              <a:buNone/>
-            </a:pPr>
-            <a:r>
-              <a:rPr lang="en-US" sz="1100" dirty="0">
+      <p:sp>
+        <p:nvSpPr>
+          <p:cNvPr id="18" name="Text 16"/>
+          <p:cNvSpPr/>
+          <p:nvPr/>
+        </p:nvSpPr>
+        <p:spPr>
+          <a:xfrm>
+            <a:off x="777240" y="3136392"/>
+            <a:ext cx="1371600" cy="256032"/>
+          </a:xfrm>
+          <a:prstGeom prst="rect">
+            <a:avLst/>
+          </a:prstGeom>
+          <a:noFill/>
+          <a:ln/>
+        </p:spPr>
+        <p:txBody>
+          <a:bodyPr wrap="square" lIns="0" tIns="0" rIns="0" bIns="0" rtlCol="0" anchor="ctr"/>
+          <a:lstStyle/>
+          <a:p>
+            <a:pPr indent="0" marL="0">
+              <a:buNone/>
+            </a:pPr>
+            <a:r>
+              <a:rPr lang="en-US" sz="1200" b="1" dirty="0">
+                <a:solidFill>
+                  <a:srgbClr val="FCD34D"/>
+                </a:solidFill>
+              </a:rPr>
+              <a:t>IPFS</a:t>
+            </a:r>
+            <a:endParaRPr lang="en-US" sz="1200" dirty="0"/>
+          </a:p>
+        </p:txBody>
+      </p:sp>
+      <p:sp>
+        <p:nvSpPr>
+          <p:cNvPr id="19" name="Text 17"/>
+          <p:cNvSpPr/>
+          <p:nvPr/>
+        </p:nvSpPr>
+        <p:spPr>
+          <a:xfrm>
+            <a:off x="777240" y="3392424"/>
+            <a:ext cx="3520440" cy="256032"/>
+          </a:xfrm>
+          <a:prstGeom prst="rect">
+            <a:avLst/>
+          </a:prstGeom>
+          <a:noFill/>
+          <a:ln/>
+        </p:spPr>
+        <p:txBody>
+          <a:bodyPr wrap="square" lIns="0" tIns="0" rIns="0" bIns="0" rtlCol="0" anchor="ctr"/>
+          <a:lstStyle/>
+          <a:p>
+            <a:pPr indent="0" marL="0">
+              <a:buNone/>
+            </a:pPr>
+            <a:r>
+              <a:rPr lang="en-US" sz="1000" dirty="0">
                 <a:solidFill>
                   <a:srgbClr val="9CA3AF"/>
                 </a:solidFill>
@@ -10654,28 +11341,28 @@
                 <a:ea typeface="Calibri" pitchFamily="34" charset="-122"/>
                 <a:cs typeface="Calibri" pitchFamily="34" charset="-120"/>
               </a:rPr>
-              <a:t>Recognized as a credential tier. Increases bid weight.</a:t>
-            </a:r>
-            <a:endParaRPr lang="en-US" sz="1100" dirty="0"/>
-          </a:p>
-        </p:txBody>
-      </p:sp>
-      <p:sp>
-        <p:nvSpPr>
-          <p:cNvPr id="26" name="Shape 20"/>
-          <p:cNvSpPr/>
-          <p:nvPr/>
-        </p:nvSpPr>
-        <p:spPr>
-          <a:xfrm>
-            <a:off x="274320" y="4206240"/>
-            <a:ext cx="4160520" cy="685800"/>
-          </a:xfrm>
-          <a:prstGeom prst="rect">
-            <a:avLst/>
-          </a:prstGeom>
-          <a:solidFill>
-            <a:srgbClr val="374151"/>
+              <a:t>Decentralized file storage for credential documents and job evidence</a:t>
+            </a:r>
+            <a:endParaRPr lang="en-US" sz="1000" dirty="0"/>
+          </a:p>
+        </p:txBody>
+      </p:sp>
+      <p:sp>
+        <p:nvSpPr>
+          <p:cNvPr id="20" name="Shape 18"/>
+          <p:cNvSpPr/>
+          <p:nvPr/>
+        </p:nvSpPr>
+        <p:spPr>
+          <a:xfrm>
+            <a:off x="320040" y="3776472"/>
+            <a:ext cx="4114800" cy="621792"/>
+          </a:xfrm>
+          <a:prstGeom prst="rect">
+            <a:avLst/>
+          </a:prstGeom>
+          <a:solidFill>
+            <a:srgbClr val="1F2937"/>
           </a:solidFill>
           <a:ln w="12700">
             <a:solidFill>
@@ -10687,115 +11374,91 @@
       </p:sp>
       <p:sp>
         <p:nvSpPr>
-          <p:cNvPr id="27" name="Shape 21"/>
-          <p:cNvSpPr/>
-          <p:nvPr/>
-        </p:nvSpPr>
-        <p:spPr>
-          <a:xfrm>
-            <a:off x="274320" y="4206240"/>
-            <a:ext cx="54864" cy="685800"/>
-          </a:xfrm>
-          <a:prstGeom prst="rect">
-            <a:avLst/>
-          </a:prstGeom>
-          <a:solidFill>
-            <a:srgbClr val="F59E0B"/>
+          <p:cNvPr id="21" name="Shape 19"/>
+          <p:cNvSpPr/>
+          <p:nvPr/>
+        </p:nvSpPr>
+        <p:spPr>
+          <a:xfrm>
+            <a:off x="384048" y="3931920"/>
+            <a:ext cx="292608" cy="292608"/>
+          </a:xfrm>
+          <a:prstGeom prst="ellipse">
+            <a:avLst/>
+          </a:prstGeom>
+          <a:solidFill>
+            <a:srgbClr val="0D9488"/>
           </a:solidFill>
           <a:ln w="12700">
             <a:solidFill>
-              <a:srgbClr val="F59E0B"/>
+              <a:srgbClr val="0D9488"/>
             </a:solidFill>
             <a:prstDash val="solid"/>
           </a:ln>
         </p:spPr>
       </p:sp>
-      <p:pic>
-        <p:nvPicPr>
-          <p:cNvPr id="28" name="Image 4" descr="preencoded.png">    </p:cNvPr>
-          <p:cNvPicPr>
-            <a:picLocks noChangeAspect="1"/>
-          </p:cNvPicPr>
-          <p:nvPr/>
-        </p:nvPicPr>
-        <p:blipFill>
-          <a:blip r:embed="rId5"/>
-          <a:stretch>
-            <a:fillRect/>
-          </a:stretch>
-        </p:blipFill>
-        <p:spPr>
-          <a:xfrm>
-            <a:off x="411480" y="4389120"/>
-            <a:ext cx="292608" cy="292608"/>
-          </a:xfrm>
-          <a:prstGeom prst="rect">
-            <a:avLst/>
-          </a:prstGeom>
-        </p:spPr>
-      </p:pic>
-      <p:sp>
-        <p:nvSpPr>
-          <p:cNvPr id="29" name="Text 22"/>
-          <p:cNvSpPr/>
-          <p:nvPr/>
-        </p:nvSpPr>
-        <p:spPr>
-          <a:xfrm>
-            <a:off x="822960" y="4279392"/>
-            <a:ext cx="3474720" cy="292608"/>
-          </a:xfrm>
-          <a:prstGeom prst="rect">
-            <a:avLst/>
-          </a:prstGeom>
-          <a:noFill/>
-          <a:ln/>
-        </p:spPr>
-        <p:txBody>
-          <a:bodyPr wrap="square" lIns="0" tIns="0" rIns="0" bIns="0" rtlCol="0" anchor="ctr"/>
-          <a:lstStyle/>
-          <a:p>
-            <a:pPr indent="0" marL="0">
-              <a:buNone/>
-            </a:pPr>
-            <a:r>
-              <a:rPr lang="en-US" sz="1300" b="1" dirty="0">
-                <a:solidFill>
-                  <a:srgbClr val="FFFFFF"/>
-                </a:solidFill>
-              </a:rPr>
-              <a:t>National Cert Bodies</a:t>
-            </a:r>
-            <a:endParaRPr lang="en-US" sz="1300" dirty="0"/>
-          </a:p>
-        </p:txBody>
-      </p:sp>
-      <p:sp>
-        <p:nvSpPr>
-          <p:cNvPr id="30" name="Text 23"/>
-          <p:cNvSpPr/>
-          <p:nvPr/>
-        </p:nvSpPr>
-        <p:spPr>
-          <a:xfrm>
-            <a:off x="822960" y="4590288"/>
-            <a:ext cx="3474720" cy="256032"/>
-          </a:xfrm>
-          <a:prstGeom prst="rect">
-            <a:avLst/>
-          </a:prstGeom>
-          <a:noFill/>
-          <a:ln/>
-        </p:spPr>
-        <p:txBody>
-          <a:bodyPr wrap="square" lIns="0" tIns="0" rIns="0" bIns="0" rtlCol="0" anchor="ctr"/>
-          <a:lstStyle/>
-          <a:p>
-            <a:pPr indent="0" marL="0">
-              <a:buNone/>
-            </a:pPr>
-            <a:r>
-              <a:rPr lang="en-US" sz="1100" dirty="0">
+      <p:sp>
+        <p:nvSpPr>
+          <p:cNvPr id="22" name="Text 20"/>
+          <p:cNvSpPr/>
+          <p:nvPr/>
+        </p:nvSpPr>
+        <p:spPr>
+          <a:xfrm>
+            <a:off x="777240" y="3831336"/>
+            <a:ext cx="1371600" cy="256032"/>
+          </a:xfrm>
+          <a:prstGeom prst="rect">
+            <a:avLst/>
+          </a:prstGeom>
+          <a:noFill/>
+          <a:ln/>
+        </p:spPr>
+        <p:txBody>
+          <a:bodyPr wrap="square" lIns="0" tIns="0" rIns="0" bIns="0" rtlCol="0" anchor="ctr"/>
+          <a:lstStyle/>
+          <a:p>
+            <a:pPr indent="0" marL="0">
+              <a:buNone/>
+            </a:pPr>
+            <a:r>
+              <a:rPr lang="en-US" sz="1200" b="1" dirty="0">
+                <a:solidFill>
+                  <a:srgbClr val="FCD34D"/>
+                </a:solidFill>
+              </a:rPr>
+              <a:t>TDLR API</a:t>
+            </a:r>
+            <a:endParaRPr lang="en-US" sz="1200" dirty="0"/>
+          </a:p>
+        </p:txBody>
+      </p:sp>
+      <p:sp>
+        <p:nvSpPr>
+          <p:cNvPr id="23" name="Text 21"/>
+          <p:cNvSpPr/>
+          <p:nvPr/>
+        </p:nvSpPr>
+        <p:spPr>
+          <a:xfrm>
+            <a:off x="777240" y="4087368"/>
+            <a:ext cx="3520440" cy="256032"/>
+          </a:xfrm>
+          <a:prstGeom prst="rect">
+            <a:avLst/>
+          </a:prstGeom>
+          <a:noFill/>
+          <a:ln/>
+        </p:spPr>
+        <p:txBody>
+          <a:bodyPr wrap="square" lIns="0" tIns="0" rIns="0" bIns="0" rtlCol="0" anchor="ctr"/>
+          <a:lstStyle/>
+          <a:p>
+            <a:pPr indent="0" marL="0">
+              <a:buNone/>
+            </a:pPr>
+            <a:r>
+              <a:rPr lang="en-US" sz="1000" dirty="0">
                 <a:solidFill>
                   <a:srgbClr val="9CA3AF"/>
                 </a:solidFill>
@@ -10803,28 +11466,28 @@
                 <a:ea typeface="Calibri" pitchFamily="34" charset="-122"/>
                 <a:cs typeface="Calibri" pitchFamily="34" charset="-120"/>
               </a:rPr>
-              <a:t>HVAC, electrical, plumbing certs → EAS attestation on-chain.</a:t>
-            </a:r>
-            <a:endParaRPr lang="en-US" sz="1100" dirty="0"/>
-          </a:p>
-        </p:txBody>
-      </p:sp>
-      <p:sp>
-        <p:nvSpPr>
-          <p:cNvPr id="31" name="Shape 24"/>
-          <p:cNvSpPr/>
-          <p:nvPr/>
-        </p:nvSpPr>
-        <p:spPr>
-          <a:xfrm>
-            <a:off x="4617720" y="4206240"/>
-            <a:ext cx="4160520" cy="685800"/>
-          </a:xfrm>
-          <a:prstGeom prst="rect">
-            <a:avLst/>
-          </a:prstGeom>
-          <a:solidFill>
-            <a:srgbClr val="374151"/>
+              <a:t>Live license verification for 40+ Texas trades — pulled at sign-up</a:t>
+            </a:r>
+            <a:endParaRPr lang="en-US" sz="1000" dirty="0"/>
+          </a:p>
+        </p:txBody>
+      </p:sp>
+      <p:sp>
+        <p:nvSpPr>
+          <p:cNvPr id="24" name="Shape 22"/>
+          <p:cNvSpPr/>
+          <p:nvPr/>
+        </p:nvSpPr>
+        <p:spPr>
+          <a:xfrm>
+            <a:off x="320040" y="4471416"/>
+            <a:ext cx="4114800" cy="621792"/>
+          </a:xfrm>
+          <a:prstGeom prst="rect">
+            <a:avLst/>
+          </a:prstGeom>
+          <a:solidFill>
+            <a:srgbClr val="1F2937"/>
           </a:solidFill>
           <a:ln w="12700">
             <a:solidFill>
@@ -10836,115 +11499,91 @@
       </p:sp>
       <p:sp>
         <p:nvSpPr>
-          <p:cNvPr id="32" name="Shape 25"/>
-          <p:cNvSpPr/>
-          <p:nvPr/>
-        </p:nvSpPr>
-        <p:spPr>
-          <a:xfrm>
-            <a:off x="4617720" y="4206240"/>
-            <a:ext cx="54864" cy="685800"/>
-          </a:xfrm>
-          <a:prstGeom prst="rect">
-            <a:avLst/>
-          </a:prstGeom>
-          <a:solidFill>
-            <a:srgbClr val="F59E0B"/>
+          <p:cNvPr id="25" name="Shape 23"/>
+          <p:cNvSpPr/>
+          <p:nvPr/>
+        </p:nvSpPr>
+        <p:spPr>
+          <a:xfrm>
+            <a:off x="384048" y="4626864"/>
+            <a:ext cx="292608" cy="292608"/>
+          </a:xfrm>
+          <a:prstGeom prst="ellipse">
+            <a:avLst/>
+          </a:prstGeom>
+          <a:solidFill>
+            <a:srgbClr val="0D9488"/>
           </a:solidFill>
           <a:ln w="12700">
             <a:solidFill>
-              <a:srgbClr val="F59E0B"/>
+              <a:srgbClr val="0D9488"/>
             </a:solidFill>
             <a:prstDash val="solid"/>
           </a:ln>
         </p:spPr>
       </p:sp>
-      <p:pic>
-        <p:nvPicPr>
-          <p:cNvPr id="33" name="Image 5" descr="preencoded.png">    </p:cNvPr>
-          <p:cNvPicPr>
-            <a:picLocks noChangeAspect="1"/>
-          </p:cNvPicPr>
-          <p:nvPr/>
-        </p:nvPicPr>
-        <p:blipFill>
-          <a:blip r:embed="rId6"/>
-          <a:stretch>
-            <a:fillRect/>
-          </a:stretch>
-        </p:blipFill>
-        <p:spPr>
-          <a:xfrm>
-            <a:off x="4754880" y="4389120"/>
-            <a:ext cx="292608" cy="292608"/>
-          </a:xfrm>
-          <a:prstGeom prst="rect">
-            <a:avLst/>
-          </a:prstGeom>
-        </p:spPr>
-      </p:pic>
-      <p:sp>
-        <p:nvSpPr>
-          <p:cNvPr id="34" name="Text 26"/>
-          <p:cNvSpPr/>
-          <p:nvPr/>
-        </p:nvSpPr>
-        <p:spPr>
-          <a:xfrm>
-            <a:off x="5166360" y="4279392"/>
-            <a:ext cx="3474720" cy="292608"/>
-          </a:xfrm>
-          <a:prstGeom prst="rect">
-            <a:avLst/>
-          </a:prstGeom>
-          <a:noFill/>
-          <a:ln/>
-        </p:spPr>
-        <p:txBody>
-          <a:bodyPr wrap="square" lIns="0" tIns="0" rIns="0" bIns="0" rtlCol="0" anchor="ctr"/>
-          <a:lstStyle/>
-          <a:p>
-            <a:pPr indent="0" marL="0">
-              <a:buNone/>
-            </a:pPr>
-            <a:r>
-              <a:rPr lang="en-US" sz="1300" b="1" dirty="0">
-                <a:solidFill>
-                  <a:srgbClr val="FFFFFF"/>
-                </a:solidFill>
-              </a:rPr>
-              <a:t>Future DAOs &amp; Cities</a:t>
-            </a:r>
-            <a:endParaRPr lang="en-US" sz="1300" dirty="0"/>
-          </a:p>
-        </p:txBody>
-      </p:sp>
-      <p:sp>
-        <p:nvSpPr>
-          <p:cNvPr id="35" name="Text 27"/>
-          <p:cNvSpPr/>
-          <p:nvPr/>
-        </p:nvSpPr>
-        <p:spPr>
-          <a:xfrm>
-            <a:off x="5166360" y="4590288"/>
-            <a:ext cx="3474720" cy="256032"/>
-          </a:xfrm>
-          <a:prstGeom prst="rect">
-            <a:avLst/>
-          </a:prstGeom>
-          <a:noFill/>
-          <a:ln/>
-        </p:spPr>
-        <p:txBody>
-          <a:bodyPr wrap="square" lIns="0" tIns="0" rIns="0" bIns="0" rtlCol="0" anchor="ctr"/>
-          <a:lstStyle/>
-          <a:p>
-            <a:pPr indent="0" marL="0">
-              <a:buNone/>
-            </a:pPr>
-            <a:r>
-              <a:rPr lang="en-US" sz="1100" dirty="0">
+      <p:sp>
+        <p:nvSpPr>
+          <p:cNvPr id="26" name="Text 24"/>
+          <p:cNvSpPr/>
+          <p:nvPr/>
+        </p:nvSpPr>
+        <p:spPr>
+          <a:xfrm>
+            <a:off x="777240" y="4526280"/>
+            <a:ext cx="1371600" cy="256032"/>
+          </a:xfrm>
+          <a:prstGeom prst="rect">
+            <a:avLst/>
+          </a:prstGeom>
+          <a:noFill/>
+          <a:ln/>
+        </p:spPr>
+        <p:txBody>
+          <a:bodyPr wrap="square" lIns="0" tIns="0" rIns="0" bIns="0" rtlCol="0" anchor="ctr"/>
+          <a:lstStyle/>
+          <a:p>
+            <a:pPr indent="0" marL="0">
+              <a:buNone/>
+            </a:pPr>
+            <a:r>
+              <a:rPr lang="en-US" sz="1200" b="1" dirty="0">
+                <a:solidFill>
+                  <a:srgbClr val="FCD34D"/>
+                </a:solidFill>
+              </a:rPr>
+              <a:t>Bonfire</a:t>
+            </a:r>
+            <a:endParaRPr lang="en-US" sz="1200" dirty="0"/>
+          </a:p>
+        </p:txBody>
+      </p:sp>
+      <p:sp>
+        <p:nvSpPr>
+          <p:cNvPr id="27" name="Text 25"/>
+          <p:cNvSpPr/>
+          <p:nvPr/>
+        </p:nvSpPr>
+        <p:spPr>
+          <a:xfrm>
+            <a:off x="777240" y="4782312"/>
+            <a:ext cx="3520440" cy="256032"/>
+          </a:xfrm>
+          <a:prstGeom prst="rect">
+            <a:avLst/>
+          </a:prstGeom>
+          <a:noFill/>
+          <a:ln/>
+        </p:spPr>
+        <p:txBody>
+          <a:bodyPr wrap="square" lIns="0" tIns="0" rIns="0" bIns="0" rtlCol="0" anchor="ctr"/>
+          <a:lstStyle/>
+          <a:p>
+            <a:pPr indent="0" marL="0">
+              <a:buNone/>
+            </a:pPr>
+            <a:r>
+              <a:rPr lang="en-US" sz="1000" dirty="0">
                 <a:solidFill>
                   <a:srgbClr val="9CA3AF"/>
                 </a:solidFill>
@@ -10952,9 +11591,695 @@
                 <a:ea typeface="Calibri" pitchFamily="34" charset="-122"/>
                 <a:cs typeface="Calibri" pitchFamily="34" charset="-120"/>
               </a:rPr>
-              <a:t>Protocol is open. Any city can deploy their own Guild on top.</a:t>
-            </a:r>
-            <a:endParaRPr lang="en-US" sz="1100" dirty="0"/>
+              <a:t>Fort Worth procurement monitoring — Scout agent scrapes open RFPs</a:t>
+            </a:r>
+            <a:endParaRPr lang="en-US" sz="1000" dirty="0"/>
+          </a:p>
+        </p:txBody>
+      </p:sp>
+      <p:sp>
+        <p:nvSpPr>
+          <p:cNvPr id="28" name="Shape 26"/>
+          <p:cNvSpPr/>
+          <p:nvPr/>
+        </p:nvSpPr>
+        <p:spPr>
+          <a:xfrm>
+            <a:off x="4800600" y="1261872"/>
+            <a:ext cx="1691640" cy="329184"/>
+          </a:xfrm>
+          <a:prstGeom prst="rect">
+            <a:avLst/>
+          </a:prstGeom>
+          <a:solidFill>
+            <a:srgbClr val="374151"/>
+          </a:solidFill>
+          <a:ln w="12700">
+            <a:solidFill>
+              <a:srgbClr val="374151"/>
+            </a:solidFill>
+            <a:prstDash val="solid"/>
+          </a:ln>
+        </p:spPr>
+      </p:sp>
+      <p:sp>
+        <p:nvSpPr>
+          <p:cNvPr id="29" name="Text 27"/>
+          <p:cNvSpPr/>
+          <p:nvPr/>
+        </p:nvSpPr>
+        <p:spPr>
+          <a:xfrm>
+            <a:off x="4800600" y="1261872"/>
+            <a:ext cx="1691640" cy="329184"/>
+          </a:xfrm>
+          <a:prstGeom prst="rect">
+            <a:avLst/>
+          </a:prstGeom>
+          <a:noFill/>
+          <a:ln/>
+        </p:spPr>
+        <p:txBody>
+          <a:bodyPr wrap="square" lIns="0" tIns="0" rIns="0" bIns="0" rtlCol="0" anchor="ctr"/>
+          <a:lstStyle/>
+          <a:p>
+            <a:pPr algn="ctr" indent="0" marL="0">
+              <a:buNone/>
+            </a:pPr>
+            <a:r>
+              <a:rPr lang="en-US" sz="1000" b="1" spc="100" kern="0" dirty="0">
+                <a:solidFill>
+                  <a:srgbClr val="9CA3AF"/>
+                </a:solidFill>
+              </a:rPr>
+              <a:t>ON THE ROADMAP</a:t>
+            </a:r>
+            <a:endParaRPr lang="en-US" sz="1000" dirty="0"/>
+          </a:p>
+        </p:txBody>
+      </p:sp>
+      <p:sp>
+        <p:nvSpPr>
+          <p:cNvPr id="30" name="Shape 28"/>
+          <p:cNvSpPr/>
+          <p:nvPr/>
+        </p:nvSpPr>
+        <p:spPr>
+          <a:xfrm>
+            <a:off x="4800600" y="1691640"/>
+            <a:ext cx="4114800" cy="621792"/>
+          </a:xfrm>
+          <a:prstGeom prst="rect">
+            <a:avLst/>
+          </a:prstGeom>
+          <a:solidFill>
+            <a:srgbClr val="1F2937"/>
+          </a:solidFill>
+          <a:ln w="12700">
+            <a:solidFill>
+              <a:srgbClr val="374151"/>
+            </a:solidFill>
+            <a:prstDash val="solid"/>
+          </a:ln>
+        </p:spPr>
+      </p:sp>
+      <p:sp>
+        <p:nvSpPr>
+          <p:cNvPr id="31" name="Shape 29"/>
+          <p:cNvSpPr/>
+          <p:nvPr/>
+        </p:nvSpPr>
+        <p:spPr>
+          <a:xfrm>
+            <a:off x="4864608" y="1847088"/>
+            <a:ext cx="292608" cy="292608"/>
+          </a:xfrm>
+          <a:prstGeom prst="ellipse">
+            <a:avLst/>
+          </a:prstGeom>
+          <a:solidFill>
+            <a:srgbClr val="374151"/>
+          </a:solidFill>
+          <a:ln w="12700">
+            <a:solidFill>
+              <a:srgbClr val="9CA3AF"/>
+            </a:solidFill>
+            <a:prstDash val="solid"/>
+          </a:ln>
+        </p:spPr>
+      </p:sp>
+      <p:sp>
+        <p:nvSpPr>
+          <p:cNvPr id="32" name="Text 30"/>
+          <p:cNvSpPr/>
+          <p:nvPr/>
+        </p:nvSpPr>
+        <p:spPr>
+          <a:xfrm>
+            <a:off x="5257800" y="1746504"/>
+            <a:ext cx="2011680" cy="256032"/>
+          </a:xfrm>
+          <a:prstGeom prst="rect">
+            <a:avLst/>
+          </a:prstGeom>
+          <a:noFill/>
+          <a:ln/>
+        </p:spPr>
+        <p:txBody>
+          <a:bodyPr wrap="square" lIns="0" tIns="0" rIns="0" bIns="0" rtlCol="0" anchor="ctr"/>
+          <a:lstStyle/>
+          <a:p>
+            <a:pPr indent="0" marL="0">
+              <a:buNone/>
+            </a:pPr>
+            <a:r>
+              <a:rPr lang="en-US" sz="1200" b="1" dirty="0">
+                <a:solidFill>
+                  <a:srgbClr val="FFFFFF"/>
+                </a:solidFill>
+              </a:rPr>
+              <a:t>Peer Jury Disputes</a:t>
+            </a:r>
+            <a:endParaRPr lang="en-US" sz="1200" dirty="0"/>
+          </a:p>
+        </p:txBody>
+      </p:sp>
+      <p:sp>
+        <p:nvSpPr>
+          <p:cNvPr id="33" name="Text 31"/>
+          <p:cNvSpPr/>
+          <p:nvPr/>
+        </p:nvSpPr>
+        <p:spPr>
+          <a:xfrm>
+            <a:off x="5257800" y="2002536"/>
+            <a:ext cx="3520440" cy="256032"/>
+          </a:xfrm>
+          <a:prstGeom prst="rect">
+            <a:avLst/>
+          </a:prstGeom>
+          <a:noFill/>
+          <a:ln/>
+        </p:spPr>
+        <p:txBody>
+          <a:bodyPr wrap="square" lIns="0" tIns="0" rIns="0" bIns="0" rtlCol="0" anchor="ctr"/>
+          <a:lstStyle/>
+          <a:p>
+            <a:pPr indent="0" marL="0">
+              <a:buNone/>
+            </a:pPr>
+            <a:r>
+              <a:rPr lang="en-US" sz="1000" dirty="0">
+                <a:solidFill>
+                  <a:srgbClr val="9CA3AF"/>
+                </a:solidFill>
+                <a:latin typeface="Calibri" pitchFamily="34" charset="0"/>
+                <a:ea typeface="Calibri" pitchFamily="34" charset="-122"/>
+                <a:cs typeface="Calibri" pitchFamily="34" charset="-120"/>
+              </a:rPr>
+              <a:t>On-chain evidence + staked jurors resolve milestone disagreements</a:t>
+            </a:r>
+            <a:endParaRPr lang="en-US" sz="1000" dirty="0"/>
+          </a:p>
+        </p:txBody>
+      </p:sp>
+      <p:sp>
+        <p:nvSpPr>
+          <p:cNvPr id="34" name="Shape 32"/>
+          <p:cNvSpPr/>
+          <p:nvPr/>
+        </p:nvSpPr>
+        <p:spPr>
+          <a:xfrm>
+            <a:off x="4800600" y="2386584"/>
+            <a:ext cx="4114800" cy="621792"/>
+          </a:xfrm>
+          <a:prstGeom prst="rect">
+            <a:avLst/>
+          </a:prstGeom>
+          <a:solidFill>
+            <a:srgbClr val="1F2937"/>
+          </a:solidFill>
+          <a:ln w="12700">
+            <a:solidFill>
+              <a:srgbClr val="374151"/>
+            </a:solidFill>
+            <a:prstDash val="solid"/>
+          </a:ln>
+        </p:spPr>
+      </p:sp>
+      <p:sp>
+        <p:nvSpPr>
+          <p:cNvPr id="35" name="Shape 33"/>
+          <p:cNvSpPr/>
+          <p:nvPr/>
+        </p:nvSpPr>
+        <p:spPr>
+          <a:xfrm>
+            <a:off x="4864608" y="2542032"/>
+            <a:ext cx="292608" cy="292608"/>
+          </a:xfrm>
+          <a:prstGeom prst="ellipse">
+            <a:avLst/>
+          </a:prstGeom>
+          <a:solidFill>
+            <a:srgbClr val="374151"/>
+          </a:solidFill>
+          <a:ln w="12700">
+            <a:solidFill>
+              <a:srgbClr val="9CA3AF"/>
+            </a:solidFill>
+            <a:prstDash val="solid"/>
+          </a:ln>
+        </p:spPr>
+      </p:sp>
+      <p:sp>
+        <p:nvSpPr>
+          <p:cNvPr id="36" name="Text 34"/>
+          <p:cNvSpPr/>
+          <p:nvPr/>
+        </p:nvSpPr>
+        <p:spPr>
+          <a:xfrm>
+            <a:off x="5257800" y="2441448"/>
+            <a:ext cx="2011680" cy="256032"/>
+          </a:xfrm>
+          <a:prstGeom prst="rect">
+            <a:avLst/>
+          </a:prstGeom>
+          <a:noFill/>
+          <a:ln/>
+        </p:spPr>
+        <p:txBody>
+          <a:bodyPr wrap="square" lIns="0" tIns="0" rIns="0" bIns="0" rtlCol="0" anchor="ctr"/>
+          <a:lstStyle/>
+          <a:p>
+            <a:pPr indent="0" marL="0">
+              <a:buNone/>
+            </a:pPr>
+            <a:r>
+              <a:rPr lang="en-US" sz="1200" b="1" dirty="0">
+                <a:solidFill>
+                  <a:srgbClr val="FFFFFF"/>
+                </a:solidFill>
+              </a:rPr>
+              <a:t>Partial Payments</a:t>
+            </a:r>
+            <a:endParaRPr lang="en-US" sz="1200" dirty="0"/>
+          </a:p>
+        </p:txBody>
+      </p:sp>
+      <p:sp>
+        <p:nvSpPr>
+          <p:cNvPr id="37" name="Text 35"/>
+          <p:cNvSpPr/>
+          <p:nvPr/>
+        </p:nvSpPr>
+        <p:spPr>
+          <a:xfrm>
+            <a:off x="5257800" y="2697480"/>
+            <a:ext cx="3520440" cy="256032"/>
+          </a:xfrm>
+          <a:prstGeom prst="rect">
+            <a:avLst/>
+          </a:prstGeom>
+          <a:noFill/>
+          <a:ln/>
+        </p:spPr>
+        <p:txBody>
+          <a:bodyPr wrap="square" lIns="0" tIns="0" rIns="0" bIns="0" rtlCol="0" anchor="ctr"/>
+          <a:lstStyle/>
+          <a:p>
+            <a:pPr indent="0" marL="0">
+              <a:buNone/>
+            </a:pPr>
+            <a:r>
+              <a:rPr lang="en-US" sz="1000" dirty="0">
+                <a:solidFill>
+                  <a:srgbClr val="9CA3AF"/>
+                </a:solidFill>
+                <a:latin typeface="Calibri" pitchFamily="34" charset="0"/>
+                <a:ea typeface="Calibri" pitchFamily="34" charset="-122"/>
+                <a:cs typeface="Calibri" pitchFamily="34" charset="-120"/>
+              </a:rPr>
+              <a:t>Proportional escrow release for partially completed milestones</a:t>
+            </a:r>
+            <a:endParaRPr lang="en-US" sz="1000" dirty="0"/>
+          </a:p>
+        </p:txBody>
+      </p:sp>
+      <p:sp>
+        <p:nvSpPr>
+          <p:cNvPr id="38" name="Shape 36"/>
+          <p:cNvSpPr/>
+          <p:nvPr/>
+        </p:nvSpPr>
+        <p:spPr>
+          <a:xfrm>
+            <a:off x="4800600" y="3081528"/>
+            <a:ext cx="4114800" cy="621792"/>
+          </a:xfrm>
+          <a:prstGeom prst="rect">
+            <a:avLst/>
+          </a:prstGeom>
+          <a:solidFill>
+            <a:srgbClr val="1F2937"/>
+          </a:solidFill>
+          <a:ln w="12700">
+            <a:solidFill>
+              <a:srgbClr val="374151"/>
+            </a:solidFill>
+            <a:prstDash val="solid"/>
+          </a:ln>
+        </p:spPr>
+      </p:sp>
+      <p:sp>
+        <p:nvSpPr>
+          <p:cNvPr id="39" name="Shape 37"/>
+          <p:cNvSpPr/>
+          <p:nvPr/>
+        </p:nvSpPr>
+        <p:spPr>
+          <a:xfrm>
+            <a:off x="4864608" y="3236976"/>
+            <a:ext cx="292608" cy="292608"/>
+          </a:xfrm>
+          <a:prstGeom prst="ellipse">
+            <a:avLst/>
+          </a:prstGeom>
+          <a:solidFill>
+            <a:srgbClr val="374151"/>
+          </a:solidFill>
+          <a:ln w="12700">
+            <a:solidFill>
+              <a:srgbClr val="9CA3AF"/>
+            </a:solidFill>
+            <a:prstDash val="solid"/>
+          </a:ln>
+        </p:spPr>
+      </p:sp>
+      <p:sp>
+        <p:nvSpPr>
+          <p:cNvPr id="40" name="Text 38"/>
+          <p:cNvSpPr/>
+          <p:nvPr/>
+        </p:nvSpPr>
+        <p:spPr>
+          <a:xfrm>
+            <a:off x="5257800" y="3136392"/>
+            <a:ext cx="2011680" cy="256032"/>
+          </a:xfrm>
+          <a:prstGeom prst="rect">
+            <a:avLst/>
+          </a:prstGeom>
+          <a:noFill/>
+          <a:ln/>
+        </p:spPr>
+        <p:txBody>
+          <a:bodyPr wrap="square" lIns="0" tIns="0" rIns="0" bIns="0" rtlCol="0" anchor="ctr"/>
+          <a:lstStyle/>
+          <a:p>
+            <a:pPr indent="0" marL="0">
+              <a:buNone/>
+            </a:pPr>
+            <a:r>
+              <a:rPr lang="en-US" sz="1200" b="1" dirty="0">
+                <a:solidFill>
+                  <a:srgbClr val="FFFFFF"/>
+                </a:solidFill>
+              </a:rPr>
+              <a:t>DAO Governance Voting</a:t>
+            </a:r>
+            <a:endParaRPr lang="en-US" sz="1200" dirty="0"/>
+          </a:p>
+        </p:txBody>
+      </p:sp>
+      <p:sp>
+        <p:nvSpPr>
+          <p:cNvPr id="41" name="Text 39"/>
+          <p:cNvSpPr/>
+          <p:nvPr/>
+        </p:nvSpPr>
+        <p:spPr>
+          <a:xfrm>
+            <a:off x="5257800" y="3392424"/>
+            <a:ext cx="3520440" cy="256032"/>
+          </a:xfrm>
+          <a:prstGeom prst="rect">
+            <a:avLst/>
+          </a:prstGeom>
+          <a:noFill/>
+          <a:ln/>
+        </p:spPr>
+        <p:txBody>
+          <a:bodyPr wrap="square" lIns="0" tIns="0" rIns="0" bIns="0" rtlCol="0" anchor="ctr"/>
+          <a:lstStyle/>
+          <a:p>
+            <a:pPr indent="0" marL="0">
+              <a:buNone/>
+            </a:pPr>
+            <a:r>
+              <a:rPr lang="en-US" sz="1000" dirty="0">
+                <a:solidFill>
+                  <a:srgbClr val="9CA3AF"/>
+                </a:solidFill>
+                <a:latin typeface="Calibri" pitchFamily="34" charset="0"/>
+                <a:ea typeface="Calibri" pitchFamily="34" charset="-122"/>
+                <a:cs typeface="Calibri" pitchFamily="34" charset="-120"/>
+              </a:rPr>
+              <a:t>Token-weighted on-chain votes for protocol parameters and treasury</a:t>
+            </a:r>
+            <a:endParaRPr lang="en-US" sz="1000" dirty="0"/>
+          </a:p>
+        </p:txBody>
+      </p:sp>
+      <p:sp>
+        <p:nvSpPr>
+          <p:cNvPr id="42" name="Shape 40"/>
+          <p:cNvSpPr/>
+          <p:nvPr/>
+        </p:nvSpPr>
+        <p:spPr>
+          <a:xfrm>
+            <a:off x="4800600" y="3776472"/>
+            <a:ext cx="4114800" cy="621792"/>
+          </a:xfrm>
+          <a:prstGeom prst="rect">
+            <a:avLst/>
+          </a:prstGeom>
+          <a:solidFill>
+            <a:srgbClr val="1F2937"/>
+          </a:solidFill>
+          <a:ln w="12700">
+            <a:solidFill>
+              <a:srgbClr val="374151"/>
+            </a:solidFill>
+            <a:prstDash val="solid"/>
+          </a:ln>
+        </p:spPr>
+      </p:sp>
+      <p:sp>
+        <p:nvSpPr>
+          <p:cNvPr id="43" name="Shape 41"/>
+          <p:cNvSpPr/>
+          <p:nvPr/>
+        </p:nvSpPr>
+        <p:spPr>
+          <a:xfrm>
+            <a:off x="4864608" y="3931920"/>
+            <a:ext cx="292608" cy="292608"/>
+          </a:xfrm>
+          <a:prstGeom prst="ellipse">
+            <a:avLst/>
+          </a:prstGeom>
+          <a:solidFill>
+            <a:srgbClr val="374151"/>
+          </a:solidFill>
+          <a:ln w="12700">
+            <a:solidFill>
+              <a:srgbClr val="9CA3AF"/>
+            </a:solidFill>
+            <a:prstDash val="solid"/>
+          </a:ln>
+        </p:spPr>
+      </p:sp>
+      <p:sp>
+        <p:nvSpPr>
+          <p:cNvPr id="44" name="Text 42"/>
+          <p:cNvSpPr/>
+          <p:nvPr/>
+        </p:nvSpPr>
+        <p:spPr>
+          <a:xfrm>
+            <a:off x="5257800" y="3831336"/>
+            <a:ext cx="2011680" cy="256032"/>
+          </a:xfrm>
+          <a:prstGeom prst="rect">
+            <a:avLst/>
+          </a:prstGeom>
+          <a:noFill/>
+          <a:ln/>
+        </p:spPr>
+        <p:txBody>
+          <a:bodyPr wrap="square" lIns="0" tIns="0" rIns="0" bIns="0" rtlCol="0" anchor="ctr"/>
+          <a:lstStyle/>
+          <a:p>
+            <a:pPr indent="0" marL="0">
+              <a:buNone/>
+            </a:pPr>
+            <a:r>
+              <a:rPr lang="en-US" sz="1200" b="1" dirty="0">
+                <a:solidFill>
+                  <a:srgbClr val="FFFFFF"/>
+                </a:solidFill>
+              </a:rPr>
+              <a:t>City Procurement API</a:t>
+            </a:r>
+            <a:endParaRPr lang="en-US" sz="1200" dirty="0"/>
+          </a:p>
+        </p:txBody>
+      </p:sp>
+      <p:sp>
+        <p:nvSpPr>
+          <p:cNvPr id="45" name="Text 43"/>
+          <p:cNvSpPr/>
+          <p:nvPr/>
+        </p:nvSpPr>
+        <p:spPr>
+          <a:xfrm>
+            <a:off x="5257800" y="4087368"/>
+            <a:ext cx="3520440" cy="256032"/>
+          </a:xfrm>
+          <a:prstGeom prst="rect">
+            <a:avLst/>
+          </a:prstGeom>
+          <a:noFill/>
+          <a:ln/>
+        </p:spPr>
+        <p:txBody>
+          <a:bodyPr wrap="square" lIns="0" tIns="0" rIns="0" bIns="0" rtlCol="0" anchor="ctr"/>
+          <a:lstStyle/>
+          <a:p>
+            <a:pPr indent="0" marL="0">
+              <a:buNone/>
+            </a:pPr>
+            <a:r>
+              <a:rPr lang="en-US" sz="1000" dirty="0">
+                <a:solidFill>
+                  <a:srgbClr val="9CA3AF"/>
+                </a:solidFill>
+                <a:latin typeface="Calibri" pitchFamily="34" charset="0"/>
+                <a:ea typeface="Calibri" pitchFamily="34" charset="-122"/>
+                <a:cs typeface="Calibri" pitchFamily="34" charset="-120"/>
+              </a:rPr>
+              <a:t>Direct sub-threshold job posting from Fort Worth city departments</a:t>
+            </a:r>
+            <a:endParaRPr lang="en-US" sz="1000" dirty="0"/>
+          </a:p>
+        </p:txBody>
+      </p:sp>
+      <p:sp>
+        <p:nvSpPr>
+          <p:cNvPr id="46" name="Shape 44"/>
+          <p:cNvSpPr/>
+          <p:nvPr/>
+        </p:nvSpPr>
+        <p:spPr>
+          <a:xfrm>
+            <a:off x="4800600" y="4471416"/>
+            <a:ext cx="4114800" cy="621792"/>
+          </a:xfrm>
+          <a:prstGeom prst="rect">
+            <a:avLst/>
+          </a:prstGeom>
+          <a:solidFill>
+            <a:srgbClr val="1F2937"/>
+          </a:solidFill>
+          <a:ln w="12700">
+            <a:solidFill>
+              <a:srgbClr val="374151"/>
+            </a:solidFill>
+            <a:prstDash val="solid"/>
+          </a:ln>
+        </p:spPr>
+      </p:sp>
+      <p:sp>
+        <p:nvSpPr>
+          <p:cNvPr id="47" name="Shape 45"/>
+          <p:cNvSpPr/>
+          <p:nvPr/>
+        </p:nvSpPr>
+        <p:spPr>
+          <a:xfrm>
+            <a:off x="4864608" y="4626864"/>
+            <a:ext cx="292608" cy="292608"/>
+          </a:xfrm>
+          <a:prstGeom prst="ellipse">
+            <a:avLst/>
+          </a:prstGeom>
+          <a:solidFill>
+            <a:srgbClr val="374151"/>
+          </a:solidFill>
+          <a:ln w="12700">
+            <a:solidFill>
+              <a:srgbClr val="9CA3AF"/>
+            </a:solidFill>
+            <a:prstDash val="solid"/>
+          </a:ln>
+        </p:spPr>
+      </p:sp>
+      <p:sp>
+        <p:nvSpPr>
+          <p:cNvPr id="48" name="Text 46"/>
+          <p:cNvSpPr/>
+          <p:nvPr/>
+        </p:nvSpPr>
+        <p:spPr>
+          <a:xfrm>
+            <a:off x="5257800" y="4526280"/>
+            <a:ext cx="2011680" cy="256032"/>
+          </a:xfrm>
+          <a:prstGeom prst="rect">
+            <a:avLst/>
+          </a:prstGeom>
+          <a:noFill/>
+          <a:ln/>
+        </p:spPr>
+        <p:txBody>
+          <a:bodyPr wrap="square" lIns="0" tIns="0" rIns="0" bIns="0" rtlCol="0" anchor="ctr"/>
+          <a:lstStyle/>
+          <a:p>
+            <a:pPr indent="0" marL="0">
+              <a:buNone/>
+            </a:pPr>
+            <a:r>
+              <a:rPr lang="en-US" sz="1200" b="1" dirty="0">
+                <a:solidFill>
+                  <a:srgbClr val="FFFFFF"/>
+                </a:solidFill>
+              </a:rPr>
+              <a:t>Multi-City Expansion</a:t>
+            </a:r>
+            <a:endParaRPr lang="en-US" sz="1200" dirty="0"/>
+          </a:p>
+        </p:txBody>
+      </p:sp>
+      <p:sp>
+        <p:nvSpPr>
+          <p:cNvPr id="49" name="Text 47"/>
+          <p:cNvSpPr/>
+          <p:nvPr/>
+        </p:nvSpPr>
+        <p:spPr>
+          <a:xfrm>
+            <a:off x="5257800" y="4782312"/>
+            <a:ext cx="3520440" cy="256032"/>
+          </a:xfrm>
+          <a:prstGeom prst="rect">
+            <a:avLst/>
+          </a:prstGeom>
+          <a:noFill/>
+          <a:ln/>
+        </p:spPr>
+        <p:txBody>
+          <a:bodyPr wrap="square" lIns="0" tIns="0" rIns="0" bIns="0" rtlCol="0" anchor="ctr"/>
+          <a:lstStyle/>
+          <a:p>
+            <a:pPr indent="0" marL="0">
+              <a:buNone/>
+            </a:pPr>
+            <a:r>
+              <a:rPr lang="en-US" sz="1000" dirty="0">
+                <a:solidFill>
+                  <a:srgbClr val="9CA3AF"/>
+                </a:solidFill>
+                <a:latin typeface="Calibri" pitchFamily="34" charset="0"/>
+                <a:ea typeface="Calibri" pitchFamily="34" charset="-122"/>
+                <a:cs typeface="Calibri" pitchFamily="34" charset="-120"/>
+              </a:rPr>
+              <a:t>Protocol is open — any city can deploy their own Guild on top</a:t>
+            </a:r>
+            <a:endParaRPr lang="en-US" sz="1000" dirty="0"/>
           </a:p>
         </p:txBody>
       </p:sp>

</xml_diff>